<commit_message>
Drop the Incident exercise; deepen the at-scale theory notes
The class is now two hours of slides with no post-break exercise.
Remove src/datomic_ops/exercises.clj and every reference to it: the
closing slide, the third panel of "How this deck works" (relaid out as
the deck's standard two columns), the 2:00 agenda row, and the pointers
in README, the pre-class note and labs.clj.

Expand the explanatory layer where this deck keeps it — the speaker
notes, 3,702 to 6,708 words across 41 slides. Each theory slide follows
one shape: the mechanism, why it is built that way, and the failure
signature when it is got wrong. On-slide text is unchanged; every slide
is already at content capacity, and fit: "shrink" would silently render
any addition at 9pt while still passing QA.

Regenerated: DECK_QA=1 node datomic-at-scale-deck.js prints QA clean at
41 slides, and the pptx carries no reference to the exercise.

Co-Authored-By: Claude Opus 5 (1M context) <noreply@anthropic.com>
</commit_message>
<xml_diff>
--- a/datomic-at-scale.pptx
+++ b/datomic-at-scale.pptx
@@ -46,10 +46,9 @@
     <p:sldId id="294" r:id="rId40"/>
     <p:sldId id="295" r:id="rId41"/>
     <p:sldId id="296" r:id="rId42"/>
-    <p:sldId id="297" r:id="rId43"/>
   </p:sldIdLst>
   <p:notesMasterIdLst>
-    <p:notesMasterId r:id="rId44"/>
+    <p:notesMasterId r:id="rId43"/>
   </p:notesMasterIdLst>
   <p:sldSz cx="12191695" cy="6858000"/>
   <p:notesSz cx="6858000" cy="12191695"/>
@@ -544,7 +543,8 @@
             <a:r>
               <a:rPr lang="en-US" dirty="0"/>
               <a:t>Fifth class in the series. It continues from *Datomic in Production*: the deployment map, the write path, the read path and the backup/restore drill are covered there and are not repeated here.
-The question this class answers: how does a Datomic system behave in production — what each component does when it fails, how failover works, what a read costs at each cache tier, where parallelism applies, which settings matter, and how peers are shipped.</a:t>
+The question this class answers: how does a Datomic system behave in production — what each component does when it fails, how failover works, what a read costs at each cache tier, where parallelism applies, which settings matter, and how peers are shipped.
+Two hours, six parts, one part per question. The labs are reached from waypoint boxes and are optional at every point: the slides carry the model on their own.</a:t>
             </a:r>
             <a:endParaRPr lang="en-US" dirty="0"/>
           </a:p>
@@ -632,7 +632,8 @@
           <a:p>
             <a:r>
               <a:rPr lang="en-US" dirty="0"/>
-              <a:t>The whole of Datomic HA is one idea: the right to write is a lease, and the lease lives in storage. Everything else — no quorum, no consensus protocol, no split brain, no virtual IP, no failover controller — is a consequence of that one decision.</a:t>
+              <a:t>The whole of Datomic HA is one idea: the right to write is a lease, and the lease lives in storage. Everything else — no quorum, no consensus protocol, no split brain, no virtual IP, no failover controller — is a consequence of that one decision.
+A lease is a claim on storage with an expiry. The holder renews it; when renewal stops, the claim expires and another process may take it. The correctness argument is one sentence: only storage grants the lease, and storage does not disagree with itself, so two processes cannot both hold it. No quorum is needed because there is no distributed decision to make.</a:t>
             </a:r>
             <a:endParaRPr lang="en-US" dirty="0"/>
           </a:p>
@@ -723,7 +724,10 @@
               <a:t>Two identical transactor processes point at the same storage. One of them holds a lease; the other polls and waits.
 Storage is the arbiter. That matters because the lease lives where the data lives — so 'who is the writer' and 'what is committed' are decided by the same system and cannot disagree. A split brain would require storage to disagree with itself.
 There is no separate failover controller, no virtual IP, and nothing for you to operate between the two processes.
-Operational note: a standby that is working correctly prints nothing after startup. A silent standby log is the expected state, not a symptom.</a:t>
+Operational note: a standby that is working correctly prints nothing after startup. A silent standby log is the expected state, not a symptom.
+The mechanism in full: the active transactor refreshes a heartbeat in storage on an interval, and the standby polls the same location. When the heartbeat goes stale for long enough, the standby takes the lease and begins writing. That is the entire protocol.
+Why storage rather than a consensus protocol: every transaction already funnels through storage, so storage is already the serialisation point. Making it the arbiter adds no new dependency and no new failure mode.
+Failure signature: two transactors that never fail over are usually pointed at different storage. The identical sql-url in the standby properties file is not a copy-paste convenience — it is the mechanism.</a:t>
             </a:r>
             <a:endParaRPr lang="en-US" dirty="0"/>
           </a:p>
@@ -814,7 +818,9 @@
               <a:t>Two tracks, same wall clock.
 The write track has a gap: from the moment A dies to the moment B has the lease, transactions fail. The read track has no gap at all — peers are reading storage and their own caches, and neither one noticed.
 The peer reconnects on its own. No URI change, no restart, no load balancer entry to flip.
-The width of that window depends on heartbeat-interval-msec, on storage latency, and on how warm the standby's JVM is. That is three environment-specific variables, so the width is a measured number from a given environment rather than a quoted constant.</a:t>
+The width of that window depends on heartbeat-interval-msec, on storage latency, and on how warm the standby's JVM is. That is three environment-specific variables, so the width is a measured number from a given environment rather than a quoted constant.
+Why the read track has no gap: peers never asked the transactor anything to begin with. They read storage and their own caches, and they notice the transactor only when they submit a transaction.
+What a caller sees during the window depends on which side it is on. A writer fails or hangs, decided by txTimeoutMsec two slides on. A reader gets the last t the peer knows about, which is a real and consistent database value — an answer to a slightly older question, not an error.</a:t>
             </a:r>
             <a:endParaRPr lang="en-US" dirty="0"/>
           </a:p>
@@ -905,7 +911,9 @@
               <a:t>The left column is what you get. The right column is what people assume they got and did not.
 A standby is not a second copy of the data: both transactors write to the same storage, so storage loss loses everything either of them wrote. Data redundancy is storage replication's job — Postgres streaming replication, DynamoDB's own durability, whatever your storage offers.
 A standby also does not protect you from a bad transaction. Once it is committed, it is committed; recovery is restore, covered in the Production class §4.
-The rolling-upgrade line on the left is the one people undersell: the same mechanism that survives a crash lets you upgrade the transactor on purpose for the cost of one bounded write pause.</a:t>
+The rolling-upgrade line on the left is the one people undersell: the same mechanism that survives a crash lets you upgrade the transactor on purpose for the cost of one bounded write pause.
+Worth being precise about three words that get used interchangeably. Availability is what HA buys — someone can still write. Durability is what storage replication buys — the bytes survive. Recoverability is what backup buys — you can go back to a state before a mistake. Three mechanisms, three different failures.
+Failure signature: a deployment with a standby transactor and unreplicated storage has bought a shorter write pause and no protection whatsoever against losing the database.</a:t>
             </a:r>
             <a:endParaRPr lang="en-US" dirty="0"/>
           </a:p>
@@ -995,7 +1003,9 @@
               <a:rPr lang="en-US" dirty="0"/>
               <a:t>During the failover window a write has to do something. datomic.txTimeoutMsec decides what: how long a peer's write waits for a writer to exist before giving up.
 There is no correct value, only a choice about which failure your application handles better. A short timeout gives you fast, explicit failures and free threads — your callers see errors during the window. A long timeout gives you writes that survive the window — at the cost of threads parked in the peer, which under load is its own outage.
-Pick the end of the dial your caller can actually handle, then measure the window (previous waypoint) and make sure a long timeout is actually longer than it.</a:t>
+Pick the end of the dial your caller can actually handle, then measure the window (previous waypoint) and make sure a long timeout is actually longer than it.
+Mechanism: the flag bounds how long a peer blocks in d/transact when no transactor holds the lease. It does not retry faster or make failover happen sooner. It only decides when the peer gives up.
+Failure signature for a value set too long: during a failover the peer's threads fill with parked writers, the pool exhausts, and the process stops serving reads as well. A bounded write-path pause has become a read-path outage. That is the failure people do not anticipate, and the reason a long timeout needs a bounded pool behind it.</a:t>
             </a:r>
             <a:endParaRPr lang="en-US" dirty="0"/>
           </a:p>
@@ -1083,7 +1093,8 @@
           <a:p>
             <a:r>
               <a:rPr lang="en-US" dirty="0"/>
-              <a:t>Every read walks down a ladder until some tier answers. Knowing which tier answered is the whole skill: the same query is a hundred nanoseconds or ten milliseconds depending on nothing but residency.</a:t>
+              <a:t>Every read walks down a ladder until some tier answers. Knowing which tier answered is the whole skill: the same query is a hundred nanoseconds or ten milliseconds depending on nothing but residency.
+One thing to establish before the ladder: there is no query cache and no result cache anywhere in Datomic. The only thing cached is the segment, a block of the index. So caching is entirely a question of which blocks are resident, and never a question of which queries were asked before.</a:t>
             </a:r>
             <a:endParaRPr lang="en-US" dirty="0"/>
           </a:p>
@@ -1175,7 +1186,9 @@
 Tier 1, the object cache, is on-heap and holds decoded segments — nothing to deserialise, which is why it is nanoseconds to microseconds.
 Tier 2, valcache, is the addition in this class: local SSD, per peer. Its latency is not the interesting part. The interesting part is that it is the only tier that survives a process restart, which is exactly the event that empties the others.
 Tier 3, memcached, is shared over the network. Its value is not its speed but its sharing: twenty cold peers cause one storage miss instead of twenty.
-Tier 4 is storage, and storage is metered — in dollars on DynamoDB, in connections and IOPS on Postgres.</a:t>
+Tier 4 is storage, and storage is metered — in dollars on DynamoDB, in connections and IOPS on Postgres.
+Why a ladder rather than one cache: each tier trades latency for a property the tier above lacks. Tier 1 is the fastest and dies with the process. Tier 2 is slower and survives a restart. Tier 3 is slower still and is shared between processes. Storage is the slowest and is the only one that is authoritative.
+The reason the ladder needs no coherence protocol: segments are immutable and content-addressed. A segment that is present is correct, at every tier, forever. Nothing is ever invalidated, and no tier can serve a stale answer. That is what makes it safe to stack four independent caches with no protocol between them.</a:t>
             </a:r>
             <a:endParaRPr lang="en-US" dirty="0"/>
           </a:p>
@@ -1266,7 +1279,9 @@
               <a:t>Use this as the sizing conversation. Four columns, four different reasons to add a tier.
 The object cache is the only one that is always there, and it is the only one that is free. It is also the one most often left at its default.
 Valcache buys restart survival. Memcached buys sharing across peers. Storage is the tier you are trying not to reach.
-Note the last row: only memcached is shared. That is the whole reason it exists, and the reason its hit ratio is a signal worth alerting on in Part V.</a:t>
+Note the last row: only memcached is shared. That is the whole reason it exists, and the reason its hit ratio is a signal worth alerting on in Part V.
+Sizing order follows what each tier costs. Object cache first, because it costs heap you have already allocated and is the only free tier. Then choose between the two paid tiers by the failure being addressed: frequent restarts point at valcache, a large fleet points at memcached.
+Failure signature for an undersized object cache: latency that is bimodal rather than uniformly high — most calls fast, a minority slow, with the proportion moving as the working set shifts. A single average hides it completely.</a:t>
             </a:r>
             <a:endParaRPr lang="en-US" dirty="0"/>
           </a:p>
@@ -1356,7 +1371,10 @@
               <a:rPr lang="en-US" dirty="0"/>
               <a:t>You ask for one entity. The peer does not fetch one entity: it fetches the segment that entity's datoms live in, and neighbours in the index come along for free. The index-range call on the next line proves it — twenty readings, one segment, one storage hit.
 The consequence for sizing is direct: the working set is measured in segments, not in entities. A workload that touches a thousand entities scattered across the index is expensive; a workload that touches ten thousand adjacent ones may be cheap. Cache sizing follows the segments a workload touches rather than the entities it names.
-It also explains why sorted access patterns — index-range, reverse chronological scans — behave differently from random entity lookup.</a:t>
+It also explains why sorted access patterns — index-range, reverse chronological scans — behave differently from random entity lookup.
+The mechanism underneath: an index is a sorted tree whose leaves are segments holding many datoms. The peer's unit of transfer and of caching is the leaf. Nothing in the system can fetch a single datom.
+So access-pattern shape matters more than data volume. A query touching a thousand entities adjacent in the index may load a handful of segments; the same thousand entities scattered across it may load a thousand. Same result, same datom count, an order of magnitude apart in storage traffic.
+Failure signature: adding a cache tier changed nothing, and the access pattern is random along a dimension nothing is indexed by. Cache tiers do not fix a scattered access pattern. Changing what is indexed does.</a:t>
             </a:r>
             <a:endParaRPr lang="en-US" dirty="0"/>
           </a:p>
@@ -1447,7 +1465,9 @@
               <a:t>Twenty peers restart together. Twenty object caches are empty at the same instant. Twenty peers ask storage the same questions in the same second.
 On Postgres you watch it in pg_stat_database: blks_hit collapses and blks_read spikes. On DynamoDB you watch it on the bill, or in throttling.
 Nothing is broken. Every peer is correct, every query returns, and p99 goes through the roof — which is why this shows up as a mysterious post-deploy latency incident rather than as an error.
-The three mitigations are ordered by what they require. Rolling deploys require no infrastructure at all.</a:t>
+The three mitigations are ordered by what they require. Rolling deploys require no infrastructure at all.
+Why this is a herd rather than N independent slow starts: the peers are identical, restarted together, serving the same traffic, so they miss on the same segments in the same order at the same moment. Storage sees N times its normal miss rate for the length of the warm-up, which is precisely when its own latency is worst. The peers make each other slower.
+Failure signature: latency spikes correlated with deploys, no errors anywhere, and the problem resolves by itself in a few minutes. It is routinely diagnosed as a bad release and rolled back, which restarts every peer again.</a:t>
             </a:r>
             <a:endParaRPr lang="en-US" dirty="0"/>
           </a:p>
@@ -1536,7 +1556,7 @@
             <a:r>
               <a:rPr lang="en-US" dirty="0"/>
               <a:t>Slides carry the model and the diagrams. REPL work lives in src/datomic_ops/labs.clj (§0–§6) and is reached through waypoint boxes. The coupling is loose on purpose: a waypoint can be taken early, late, or skipped entirely without breaking the thread of the class.
-Labs marked [MEM] run on datomic:mem:// with nothing installed. Labs marked [PRO] need Postgres, one or two transactors and $DATOMIC — see infra/HA.md. The exercise after the break is entirely [MEM], so it does not depend on what each laptop has set up.</a:t>
+Labs marked [MEM] run on datomic:mem:// with nothing installed — every laptop in the room can run them, and the numbers on the slides came from those labs. Labs marked [PRO] need Postgres, one or two transactors and $DATOMIC — see infra/HA.md — and are demonstrated from the front, so nobody is blocked on infrastructure.</a:t>
             </a:r>
             <a:endParaRPr lang="en-US" dirty="0"/>
           </a:p>
@@ -1712,7 +1732,8 @@
           <a:p>
             <a:r>
               <a:rPr lang="en-US" dirty="0"/>
-              <a:t>Both halves of the system are described as parallel, and the word means something different on each side. On the write side it means pipelining: keeping one serial writer busy. On the read side it means actual concurrency: many cores over one immutable value.</a:t>
+              <a:t>Both halves of the system are described as parallel, and the word means something different on each side. On the write side it means pipelining: keeping one serial writer busy. On the read side it means actual concurrency: many cores over one immutable value.
+Keeping the two apart matters because they have different limits and different levers. Pipelining adds no concurrency at all — it removes idleness from a serial resource, and it is bounded by the round trip it hides. Read parallelism is ordinary concurrency, and it is bounded by cores and by cache misses. Conflating them leads to looking for threads where there are none.</a:t>
             </a:r>
             <a:endParaRPr lang="en-US" dirty="0"/>
           </a:p>
@@ -1802,7 +1823,9 @@
               <a:rPr lang="en-US" dirty="0"/>
               <a:t>Writes cannot be parallelised. One transactor, one serial order — that is what makes the transaction guarantees cheap. What writes can be is pipelined: send the next transaction before the previous one's result has come back, so the transactor never sits idle waiting on a round trip.
 Reads are parallel in the ordinary sense. Every peer, every core, over an immutable database value. Once the segments are warm those reads cost storage nothing.
-The levers therefore differ. On the left you are fighting idleness. On the right you are cutting work along the index. The two are separate mechanisms; only the read side involves concurrency.</a:t>
+The levers therefore differ. On the left you are fighting idleness. On the right you are cutting work along the index. The two are separate mechanisms; only the read side involves concurrency.
+Why writes cannot be parallelised is a statement about semantics, not implementation: transaction functions and the uniqueness and cardinality checks all evaluate against the current value of the database, so every transaction has to know its exact predecessor. Two writers would have to agree on that order, which is the coordination the single writer exists to avoid.
+Failure signature: a write-throughput problem attacked by adding transactors. There is only ever one writer. The second process is idle by design and will stay idle.</a:t>
             </a:r>
             <a:endParaRPr lang="en-US" dirty="0"/>
           </a:p>
@@ -1893,7 +1916,10 @@
               <a:t>Draw the mechanism before showing the measurement, because the measurement is a null result and only makes sense once the mechanism is clear.
 Serial: submit, wait for the round trip, get the result, submit the next. The transactor spends most of the wall clock idle, waiting on the network.
 Pipelined: submit N transactions before collecting any of them. The transactor's work is the same; the idle gaps are gone.
-So pipelining does not make the transactor faster. It stops it from waiting. That is exactly what the next slide's measurement isolates.</a:t>
+So pipelining does not make the transactor faster. It stops it from waiting. That is exactly what the next slide's measurement isolates.
+Concretely: d/transact returns a future. Serial code derefs it immediately, so the peer waits out a network round trip and a durable write before it submits the next one. Pipelined code submits several and derefs later, so those round trips overlap.
+Why depth stops paying: once enough transactions are in flight to cover the round trip, there is no idleness left to remove. Further depth only queues work, and the queue costs heap in the peer and latency per transaction with no throughput to show for it. 8 to 16 is the documented starting point; the depth that covers your round trip is a measurement, like the gap itself.
+Failure signature for unbounded pipelining: peer heap pressure and transaction latencies that grow with queue depth, with no throughput gain to show for it.</a:t>
             </a:r>
             <a:endParaRPr lang="en-US" dirty="0"/>
           </a:p>
@@ -1983,7 +2009,9 @@
               <a:rPr lang="en-US" dirty="0"/>
               <a:t>Two runs on datomic:mem://: 500,000 datoms serial, 600,000 pipelined. 24.69 ms and 24.31 ms. No difference.
 That is not a failed experiment, it is a controlled one. datomic:mem:// runs the transactor inside the same JVM, so there is no round trip. Remove the round trip and pipelining has nothing to overlap — which confirms that overlapping the round trip is all it ever did.
-Run the identical two lines against a transactor over a socket and a gap appears, proportional to that round trip. So the number is environment-specific: the gap equals the round trip being hidden, and a multiplier from a slide does not transfer.</a:t>
+Run the identical two lines against a transactor over a socket and a gap appears, proportional to that round trip. So the number is environment-specific: the gap equals the round trip being hidden, and a multiplier from a slide does not transfer.
+How to read a null result: the experiment removed exactly one variable, the round trip, and the effect vanished with it. That is the strongest evidence available that the round trip was the mechanism — stronger than a positive measurement, which would not have isolated anything.
+The consequence for quoting numbers: the pipelining speed-up is a property of the network between peer and transactor, not a property of Datomic. A figure from another environment describes that environment's network.</a:t>
             </a:r>
             <a:endParaRPr lang="en-US" dirty="0"/>
           </a:p>
@@ -2075,7 +2103,9 @@
 100,000 readings, 8 slices, pmap across 10 cores: 78.70 ms serial becomes 24.68 ms. About 3.2x, median of five runs.
 Two constraints matter more than the multiplier.
 First, db is a value. Every slice reads the same immutable database, so there is no snapshot to hold open, no read transaction to leak, and no possibility of slices disagreeing. This is the thing that is genuinely hard in a mutable database and free here.
-Second, the speed-up is bounded by cache misses rather than by cores. On a warm peer you are dividing CPU work. On a cold peer you are overlapping storage waits — which is still a win, just a different one.</a:t>
+Second, the speed-up is bounded by cache misses rather than by cores. On a warm peer you are dividing CPU work. On a cold peer you are overlapping storage waits — which is still a win, just a different one.
+Why no coordination is needed: db is a value, and a value cannot change while it is being read. There is no snapshot to open, no read lock to take, no MVCC version to keep alive, and no way for two slices to disagree. In a mutable database this is the hard part of parallel reads; here it costs nothing.
+Failure signature: pmap over slices that do almost no work is slower than serial. The coordination cost per slice is fixed, so when a slice's work is smaller than that cost, parallelism loses. Counting datoms in 250-datom slices is the reproducible example — the same code that gives 3.2x on real per-slice work.</a:t>
             </a:r>
             <a:endParaRPr lang="en-US" dirty="0"/>
           </a:p>
@@ -2167,7 +2197,9 @@
 Two things to notice.
 The degradation is gradual. Going from 8 to 1,000 slices — a 125-fold increase in coordination — costs about 22%. The curve is flat enough that an optimal slice count is not required.
 Only at 10,000 slices does the parallel version start approaching the 78.70 ms serial baseline, and even there it is still faster. Over-slicing degrades the result gradually rather than reversing it.
-In practice: slice to roughly the core count, or a small multiple of it.</a:t>
+In practice: slice to roughly the core count, or a small multiple of it.
+Why the curve is gradual rather than a cliff: the cost per slice is small and constant — a thread hand-off and a range set-up — so total overhead grows linearly with slice count while the useful work stays fixed. There is no threshold and no change of mode, which is why nothing dramatic happens anywhere on the curve.
+The practical reading is that slice count is not worth tuning. Any value near the core count sits in the flat part.</a:t>
             </a:r>
             <a:endParaRPr lang="en-US" dirty="0"/>
           </a:p>
@@ -2257,7 +2289,9 @@
               <a:rPr lang="en-US" dirty="0"/>
               <a:t>d/with applies a transaction to a database value and hands back a new value. No transactor is involved, nothing is durable, and nothing is shared — so any number of them can run at once.
 The second form is the important one: after three concurrent what-ifs each reporting 105,005 readings, the base db still reports 105,000. Immutability is what makes the concurrency safe without locking.
-Uses in production: validation before submitting, scenario analysis, and import dry runs — checking that a large load would not violate an invariant before spending transactor time on it.</a:t>
+Uses in production: validation before submitting, scenario analysis, and import dry runs — checking that a large load would not violate an invariant before spending transactor time on it.
+Mechanism: d/with runs the same transaction machinery the transactor runs, but inside the peer and against a value. It returns db-before, db-after, tx-data and tempids — everything the transactor would have reported, minus durability.
+Failure signature it prevents: discovering a uniqueness violation or a failing transaction function at commit time, on the transactor, halfway through a bulk import.</a:t>
             </a:r>
             <a:endParaRPr lang="en-US" dirty="0"/>
           </a:p>
@@ -2347,7 +2381,9 @@
               <a:rPr lang="en-US" dirty="0"/>
               <a:t>A single d/q is single-threaded inside the peer. There is no query planner hint, no degree-of-parallelism setting, and no thread pool to grow.
 So parallelism applies across queries, or across index slices that the caller cut — never within one query. If a single query is slow, the answer is its shape or its cache, not more cores.
-Parallel SQL engines behave differently here, which is why the expectation is stated explicitly.</a:t>
+Parallel SQL engines behave differently here, which is why the expectation is stated explicitly.
+Why no knob exists: a datalog query is a join over sorted index traversals, executed in one thread against local structures. Parallelising within a query would mean partitioning the join, which the engine does not do.
+Failure signature: one slow query and a peer with idle cores. The cores will not be used. The levers that remain are the query shape — clause order, indexed attributes, narrower ranges — and cache residency.</a:t>
             </a:r>
             <a:endParaRPr lang="en-US" dirty="0"/>
           </a:p>
@@ -2435,7 +2471,8 @@
           <a:p>
             <a:r>
               <a:rPr lang="en-US" dirty="0"/>
-              <a:t>Settings are lookups. The loop they all act on is what makes a red dashboard readable — it identifies which knob is relevant.</a:t>
+              <a:t>Settings are lookups. The loop they all act on is what makes a red dashboard readable — it identifies which knob is relevant.
+Every setting in this part acts on one of two loops: the memory-index loop on the write side, or the cache ladder from Part III on the read side. Placing a setting on a loop is what makes it diagnosable. Read on its own, a settings table is a list of names.</a:t>
             </a:r>
             <a:endParaRPr lang="en-US" dirty="0"/>
           </a:p>
@@ -2523,7 +2560,8 @@
           <a:p>
             <a:r>
               <a:rPr lang="en-US" dirty="0"/>
-              <a:t>Each part answers one operational question. The minute marks are a plan, not a contract — the failover drill in Part II and the parallelism measurements in Part IV are the two places where a class typically runs long, and both are worth the overrun.</a:t>
+              <a:t>Each part answers one operational question, and the six answers compose into a single model: what fails, who takes over, what a read costs, what scales, which knob, and how it ships.
+The minute marks are a plan, not a contract — the failover drill in Part II and the parallelism measurements in Part IV are the two places where a class typically runs long, and both are worth the overrun. Parts V and VI are lookups and compress well if the earlier parts ran over.</a:t>
             </a:r>
             <a:endParaRPr lang="en-US" dirty="0"/>
           </a:p>
@@ -2615,7 +2653,9 @@
 When the memory index passes memory-index-threshold, an indexing job starts draining it into storage.
 If writes keep outrunning that drain, the memory index reaches memory-index-max, and the transactor throttles the writers. p99 write latency rises.
 The throttle is intentional back-pressure protecting the transactor's heap, not a failure. But it is what appears on your dashboard as a latency incident, so knowing the loop is what stops you from tuning at random when it happens.
-Threshold starts the job. Max starts the throttling. Those two sentences describe the whole loop.</a:t>
+Threshold starts the job. Max starts the throttling. Those two sentences describe the whole loop.
+Why the loop exists at all: appending to the durable log is cheap, while updating the sorted indexes is expensive — it rewrites tree segments. Doing the second on every transaction would make every write pay index-maintenance cost. So recent writes live in an in-memory index, get merged into the durable indexes in batches, and queries read the union of the two. Durability is never deferred; only indexing is.
+Failure signature: query latency that climbs slowly between indexing jobs and drops when one finishes. That is the memory index growing and then being merged — reads are paying for the union.</a:t>
             </a:r>
             <a:endParaRPr lang="en-US" dirty="0"/>
           </a:p>
@@ -2707,7 +2747,9 @@
 Normal: the memory index sits below threshold, no indexing job running.
 Draining: past threshold, an indexing job is running, writes continue at full speed. This is the healthy steady state under sustained load, not a warning.
 Throttled: at max. The transactor deliberately slows the writers so the memory index cannot grow past what its heap can hold. Nothing is lost, nothing errors, and p99 rises.
-When you see the third state, the question is not 'how do I turn off throttling' — it is 'why is the drain slower than the write rate'. Usually that is storage write latency, or an indexing job competing with a heavy write burst.</a:t>
+When you see the third state, the question is not 'how do I turn off throttling' — it is 'why is the drain slower than the write rate'. Usually that is storage write latency, or an indexing job competing with a heavy write burst.
+Why throttling rather than failing: the memory index is bounded by the transactor's heap. Without back-pressure a sustained burst would exhaust it, which is an outage. Slowing the writers converts an outage into latency, which is the trade being made deliberately.
+Where to look, in order: the drain is storage writes plus index maintenance, so check storage write latency first and overlapping indexing jobs second. Raising memory-index-max buys a longer runway; it does not make the drain faster.</a:t>
             </a:r>
             <a:endParaRPr lang="en-US" dirty="0"/>
           </a:p>
@@ -2797,7 +2839,9 @@
               <a:rPr lang="en-US" dirty="0"/>
               <a:t>Read this table as a diagnosis aid rather than as a configuration guide: symptom on the right, knob on the left.
 The first two are the loop from two slides ago. object-cache-max is the transactor's own read cache — a transactor reads while it indexes. memcached unset means every peer misses separately, which is Part III's thundering herd. heartbeat-interval-msec directly widens or narrows Part II's failover window.
-The warning at the bottom: passing ANY JVM flag to bin/transactor makes it drop its own GC defaults. If you pass anything at all, re-specify the GC flags yourself.</a:t>
+The warning at the bottom: passing ANY JVM flag to bin/transactor makes it drop its own GC defaults. If you pass anything at all, re-specify the GC flags yourself.
+Note what the table does not contain: there is no setting that makes indexing faster. Every knob here changes when work happens or how much is buffered. Making the drain faster is a storage question, not a properties-file question.
+The GC line is a real failure signature: a transactor that starts pausing after an unrelated flag was added to bin/transactor is running on default JVM GC, not because that flag was wrong but because passing any flag at all drops the shipped defaults.</a:t>
             </a:r>
             <a:endParaRPr lang="en-US" dirty="0"/>
           </a:p>
@@ -2886,7 +2930,9 @@
             <a:r>
               <a:rPr lang="en-US" dirty="0"/>
               <a:t>The peer flags map one-to-one onto Part III's tier ladder, which is the easiest way to remember them: the first four are tiers 1, 3, 2 and 2's size limit. The fifth is Part II's dial.
-Defaults change between releases. Confirm the values against the distribution in use — the next slide is how.</a:t>
+Defaults change between releases. Confirm the values against the distribution in use — the next slide is how.
+Why the list is this short: a peer has almost nothing to tune. It has a cache ladder and one timeout. Everything else about how a peer behaves is a property of the code it runs — which queries it issues and what access pattern those produce.
+A misconfiguration worth naming: valcachePath pointed at a directory two peers share. Valcache is a per-peer cache, so a shared path buys no sharing and is not a supported way to build one. The tier that is shared on purpose is memcached.</a:t>
             </a:r>
             <a:endParaRPr lang="en-US" dirty="0"/>
           </a:p>
@@ -2976,7 +3022,8 @@
               <a:rPr lang="en-US" dirty="0"/>
               <a:t>Three commands, and they are the actual answer to 'what is the default for X'.
 The samples directory is the authoritative starting point for a properties file. The grep strips comments and blank lines so you see only what is actually set. The third one finds where a feature is wired in the scripts — useful for valcache in particular, whose flags moved between releases.
-Where the distribution and this deck disagree, the distribution is current.</a:t>
+Where the distribution and this deck disagree, the distribution is current.
+The reason to read defaults off the distribution rather than out of documentation is that defaults are release-specific, and the distribution on disk is the one that will run. It is a two-minute check that resolves most questions of the form why is this setting not taking effect before they turn into debugging.</a:t>
             </a:r>
             <a:endParaRPr lang="en-US" dirty="0"/>
           </a:p>
@@ -3067,7 +3114,9 @@
               <a:t>Both of these ship with the peer library and cost nothing to adopt.
 d/sync-index returns a database whose INDEX — not merely whose log — includes a given t. d/sync waits on the log alone. Under light load the two look identical; under load, when indexing lags behind the log, they diverge, and code that assumed d/sync was enough starts reading through the memory index instead of the index it expected.
 The tx-report queue lets any peer observe transactions as they land. The datom count in the example decomposes: 401 = 100 readings × 4 attributes + 1 :db/txInstant. A count that does not decompose is a signal about transaction shape.
-In production the queue is used for audit, cache invalidation and CDC. In class, as a throughput monitor.</a:t>
+In production the queue is used for audit, cache invalidation and CDC. In class, as a throughput monitor.
+Why sync and sync-index differ: the log receives a transaction immediately, the durable index receives it at the next merge. A database whose log includes t answers queries correctly — it just answers them by reading the memory index as well as the durable one. Under indexing lag that is a difference in cost, not in correctness.
+So sync is enough for read-your-writes, which is about a single recent transaction. sync-index is what a bulk read wants, because it wants the work already merged into the sorted index rather than merged again per query.</a:t>
             </a:r>
             <a:endParaRPr lang="en-US" dirty="0"/>
           </a:p>
@@ -3155,7 +3204,8 @@
           <a:p>
             <a:r>
               <a:rPr lang="en-US" dirty="0"/>
-              <a:t>Everything in this part follows from one fact: a peer is not stateless. It carries a cache, and that cache is the difference between a 10 ms read and a 1,000 ms one. A deployment procedure that treats peers as interchangeable stateless containers reproduces the Part III cold-cache burst on every release.</a:t>
+              <a:t>Everything in this part follows from one fact: a peer is not stateless. It carries a cache, and that cache is the difference between a 10 ms read and a 1,000 ms one. A deployment procedure that treats peers as interchangeable stateless containers reproduces the Part III cold-cache burst on every release.
+A stateless service can be replaced instance for instance with no warm-up, because nothing was accumulated. A peer accumulated a cache, and that cache took time and storage traffic to build. Everything in this part follows from that one difference.</a:t>
             </a:r>
             <a:endParaRPr lang="en-US" dirty="0"/>
           </a:p>
@@ -3245,7 +3295,9 @@
               <a:rPr lang="en-US" dirty="0"/>
               <a:t>A readiness probe that succeeds at process start reports a peer that is up and cold. It will accept traffic and serve every one of the first requests from storage.
 The fix is to make readiness mean warm. Warm the segments the service actually reads — index ranges over the attributes it queries — and only then report ready. That moves the cold-read cost ahead of the first request instead of onto it.
-Note pmap in warm!: warming uses the parallel-slice pattern from Part IV for a different purpose. And note that it returns basis-t alongside :ready? — useful for the read-your-writes contract on the next slide.</a:t>
+Note pmap in warm!: warming uses the parallel-slice pattern from Part IV for a different purpose. And note that it returns basis-t alongside :ready? — useful for the read-your-writes contract on the next slide.
+Why the default probe is wrong here rather than merely imprecise: it is not reporting the wrong thing about the process, it is reporting about the wrong subject. The process genuinely is ready. The cache is not, and the cache is what decides the latency the caller sees.
+Failure signature: the first few hundred requests to a fresh instance are slow, and the effect is gone before anyone can attach to it. It never reproduces on a warm instance, which is where people go looking.</a:t>
             </a:r>
             <a:endParaRPr lang="en-US" dirty="0"/>
           </a:p>
@@ -3335,7 +3387,10 @@
               <a:rPr lang="en-US" dirty="0"/>
               <a:t>A fresh peer starts at whatever t storage gives it. So a request that arrives just after a write made through a DIFFERENT peer can legitimately be served a database value that does not include that write. Nothing is broken; the peer is simply behind.
 The contract that fixes it is to pass the t along with the request and have the reading peer d/sync to it before answering. That is the consistency contract of a multi-peer deployment, and it belongs in the request envelope — a header or a field — rather than in a sleep.
-If what you need is the index rather than the log, sync-index, per Part V.</a:t>
+If what you need is the index rather than the log, sync-index, per Part V.
+Why the peer is behind rather than wrong: its database value is a consistent snapshot at some t. Answering from t-1 is a correct answer to a slightly older question. Nothing is corrupt and nothing will be logged as an error, which is what makes this hard to find.
+Why a sleep does not fix it: a sleep guesses at a delay that varies with load. d/sync waits on the actual condition, and a deref with a timeout also bounds the wait.
+Failure signature: a write followed by a read that does not see it, reproducible only under load or with more than one peer — and never in a single-peer test environment, which is where the code was written.</a:t>
             </a:r>
             <a:endParaRPr lang="en-US" dirty="0"/>
           </a:p>
@@ -3426,7 +3481,9 @@
               <a:t>Four steps, and step 1 is the one that differs from SQL.
 Datomic schema is additive. A new attribute is a new entity; an old peer simply never asks about it. So you ship schema first, with no lock, no ALTER, no migration window and no coordination with the code rollout. That is what makes the rest of the order safe: by the time new code arrives, the schema it needs is already there.
 Step 2 is Part III's mitigation number 3. Step 3 is the previous slide's warm!. Step 4 is Part II's failover, this time on purpose: start the new-version standby, stop the old active, spend one bounded write pause.
-From a peer's point of view, a rolling transactor upgrade and a transactor crash are indistinguishable. The same mechanism handles both, which is what makes the measured window from Part II the relevant number.</a:t>
+From a peer's point of view, a rolling transactor upgrade and a transactor crash are indistinguishable. The same mechanism handles both, which is what makes the measured window from Part II the relevant number.
+Why additive schema removes the migration window: a new attribute is a new entity in the same database, asserted by an ordinary transaction. Nothing is rewritten, nothing is locked, and no existing datom is touched. A peer that does not know the attribute never queries it. So schema can ship days ahead of the code that uses it.
+The order is not a convention — each step depends on the previous one already being true. Schema before code, so the code finds what it needs. Peers in waves before traffic, so the caches are never all cold at once. Warm before ready, so the first request is not the one that pays. Transactor last, because it is the only step that costs a write pause.</a:t>
             </a:r>
             <a:endParaRPr lang="en-US" dirty="0"/>
           </a:p>
@@ -3514,7 +3571,8 @@
           <a:p>
             <a:r>
               <a:rPr lang="en-US" dirty="0"/>
-              <a:t>The point of this part is structural, not procedural. In a single-server SQL deployment, everything that can die takes the application with it. In Datomic, three of the four things that can die do not.</a:t>
+              <a:t>The point of this part is structural, not procedural. In a single-server SQL deployment, everything that can die takes the application with it. In Datomic, three of the four things that can die do not.
+The reason is the split: query, write, cache and durability live in four processes with four lifetimes. A failure takes down a responsibility rather than the system. Everything after this part is a consequence of the split — Part II covers the writer, Part III the reader, and neither mechanism helps the other.</a:t>
             </a:r>
             <a:endParaRPr lang="en-US" dirty="0"/>
           </a:p>
@@ -3607,7 +3665,8 @@
 Waits: writers wait — during failover, and during throttling. Those are the only two places anything waits.
 Scales: reads by peers × cores, writes by pipelining, and nothing scales inside one query.
 Costs: storage, whenever a cache is cold.
-The settings tables in Part V are lookups. This table is the model they operate on.</a:t>
+The settings tables in Part V are lookups. This table is the model they operate on.
+Used as a diagnosis path: any symptom lands on one of the four rows. Writes failing is FAILS, and the question is which component. Writes slow is WAITS, and there are only two places anything waits. Reads slow is COSTS, so ask which tier answered — unless it is a single query, in which case SCALES already says that more cores will not help.</a:t>
             </a:r>
             <a:endParaRPr lang="en-US" dirty="0"/>
           </a:p>
@@ -3695,7 +3754,9 @@
           <a:p>
             <a:r>
               <a:rPr lang="en-US" dirty="0"/>
-              <a:t>src/datomic_ops/exercises.clj. The exercise is entirely [MEM], so it does not depend on what each laptop has set up. E3 applies the Part IV slicing pattern and takes the longest.</a:t>
+              <a:t>The Production class covers the paths and storage layers this class assumed. infra/HA.md has the two-transactor setup if Part II was not run live.
+On Cloud: the model is the same and the operational surface is different. Query groups are Part IV's read scaling packaged as an autoscaling group, and failover is managed by the platform rather than by you. Everything in Parts I, III, IV and V still applies.
+The failover drill is worth repeating on your own staging environment: the window depends on that infrastructure, so the applicable number is the measured one.</a:t>
             </a:r>
             <a:endParaRPr lang="en-US" dirty="0"/>
           </a:p>
@@ -3719,96 +3780,6 @@
             <a:fld id="{F7021451-1387-4CA6-816F-3879F97B5CBC}" type="slidenum">
               <a:rPr lang="en-US"/>
               <a:t>41</a:t>
-            </a:fld>
-            <a:endParaRPr lang="en-US"/>
-          </a:p>
-        </p:txBody>
-      </p:sp>
-    </p:spTree>
-    <p:extLst>
-      <p:ext uri="{BB962C8B-B14F-4D97-AF65-F5344CB8AC3E}">
-        <p14:creationId xmlns:p14="http://schemas.microsoft.com/office/powerpoint/2010/main" val="1024086991"/>
-      </p:ext>
-    </p:extLst>
-  </p:cSld>
-  <p:clrMapOvr>
-    <a:masterClrMapping/>
-  </p:clrMapOvr>
-</p:notes>
-</file>
-
-<file path=ppt/notesSlides/notesSlide42.xml><?xml version="1.0" encoding="utf-8"?>
-<p:notes xmlns:a="http://schemas.openxmlformats.org/drawingml/2006/main" xmlns:r="http://schemas.openxmlformats.org/officeDocument/2006/relationships" xmlns:p="http://schemas.openxmlformats.org/presentationml/2006/main">
-  <p:cSld>
-    <p:spTree>
-      <p:nvGrpSpPr>
-        <p:cNvPr id="1" name=""/>
-        <p:cNvGrpSpPr/>
-        <p:nvPr/>
-      </p:nvGrpSpPr>
-      <p:grpSpPr>
-        <a:xfrm>
-          <a:off x="0" y="0"/>
-          <a:ext cx="0" cy="0"/>
-          <a:chOff x="0" y="0"/>
-          <a:chExt cx="0" cy="0"/>
-        </a:xfrm>
-      </p:grpSpPr>
-      <p:sp>
-        <p:nvSpPr>
-          <p:cNvPr id="2" name="Slide Image Placeholder 1"/>
-          <p:cNvSpPr>
-            <a:spLocks noGrp="1" noRot="1" noChangeAspect="1"/>
-          </p:cNvSpPr>
-          <p:nvPr>
-            <p:ph type="sldImg"/>
-          </p:nvPr>
-        </p:nvSpPr>
-        <p:spPr/>
-      </p:sp>
-      <p:sp>
-        <p:nvSpPr>
-          <p:cNvPr id="3" name="Notes Placeholder 2"/>
-          <p:cNvSpPr>
-            <a:spLocks noGrp="1"/>
-          </p:cNvSpPr>
-          <p:nvPr>
-            <p:ph type="body" idx="1"/>
-          </p:nvPr>
-        </p:nvSpPr>
-        <p:spPr/>
-        <p:txBody>
-          <a:bodyPr/>
-          <a:lstStyle/>
-          <a:p>
-            <a:r>
-              <a:rPr lang="en-US" dirty="0"/>
-              <a:t>The Production class covers the paths and storage layers this class assumed. infra/HA.md has the two-transactor setup if Part II was not run live.
-On Cloud: the model is the same and the operational surface is different. Query groups are Part IV's read scaling packaged as an autoscaling group, and failover is managed by the platform rather than by you. Everything in Parts I, III, IV and V still applies.
-The failover drill is worth repeating on your own staging environment: the window depends on that infrastructure, so the applicable number is the measured one.</a:t>
-            </a:r>
-            <a:endParaRPr lang="en-US" dirty="0"/>
-          </a:p>
-        </p:txBody>
-      </p:sp>
-      <p:sp>
-        <p:nvSpPr>
-          <p:cNvPr id="4" name="Slide Number Placeholder 3"/>
-          <p:cNvSpPr>
-            <a:spLocks noGrp="1"/>
-          </p:cNvSpPr>
-          <p:nvPr>
-            <p:ph type="sldNum" sz="quarter" idx="10"/>
-          </p:nvPr>
-        </p:nvSpPr>
-        <p:spPr/>
-        <p:txBody>
-          <a:bodyPr/>
-          <a:lstStyle/>
-          <a:p>
-            <a:fld id="{F7021451-1387-4CA6-816F-3879F97B5CBC}" type="slidenum">
-              <a:rPr lang="en-US"/>
-              <a:t>42</a:t>
             </a:fld>
             <a:endParaRPr lang="en-US"/>
           </a:p>
@@ -3877,7 +3848,10 @@
 Peers are libraries inside your JVM. The query engine runs there — not in a server. Each peer holds its own object cache of decoded segments.
 Memcached is optional and shared: peers consult it before storage, so N cold peers cause one storage miss instead of N.
 Storage is the source of truth AND the arbiter of who may write — that second role is what Part II is about.
-Transactors: exactly one writes at a time. The standby is a parked process holding no lease.</a:t>
+Transactors: exactly one writes at a time. The standby is a parked process holding no lease.
+Two details decide most operational questions later. A peer is a library, so adding a peer means starting another instance of the application: there is no server to size, and query capacity scales with the number of application instances you already run.
+And the transactor is not in the read path at all. Peers read storage directly. That is why a dead transactor is a write outage and nothing more, and why no amount of transactor capacity makes reads faster.
+Failure signature: if reads slow down while the transactor is busy, the two are contending for storage, not for the transactor.</a:t>
             </a:r>
             <a:endParaRPr lang="en-US" dirty="0"/>
           </a:p>
@@ -3969,7 +3943,9 @@
 Storage: a total outage, and reads go down too — but only once the caches miss. A peer with a warm object cache keeps answering queries it can answer from cache for as long as its working set holds.
 Transactor: writes fail, reads continue. This is the failure people expect to be fatal and it is not.
 One peer: that peer's traffic only. Siblings are unaffected because peers share nothing but storage.
-Memcached: nothing fails. Storage load goes up, latency goes up, correctness does not move.</a:t>
+Memcached: nothing fails. Storage load goes up, latency goes up, correctness does not move.
+The blast radius of a component is the blast radius of the state only it holds. Storage holds the only copy, so losing it loses everything. The transactor holds the right to write, which another process can take. A peer holds a cache, which rebuilds. Memcached holds a copy of a cache, which also rebuilds.
+Storage is the single component here whose state exists nowhere else, and that is exactly the one card marked as an outage.</a:t>
             </a:r>
             <a:endParaRPr lang="en-US" dirty="0"/>
           </a:p>
@@ -4058,7 +4034,8 @@
             <a:r>
               <a:rPr lang="en-US" dirty="0"/>
               <a:t>On the left, one process is the query engine, the writer, the cache and the durability boundary at once, so every failure is the same failure. On the right, those four responsibilities live in different processes and fail separately.
-The rest of the class follows from the split: Part II protects the write path only, Part III accelerates the read path only, and Part IV finds that the two words for 'parallelism' mean different mechanisms on each side.</a:t>
+The rest of the class follows from the split: Part II protects the write path only, Part III accelerates the read path only, and Part IV finds that the two words for 'parallelism' mean different mechanisms on each side.
+The practical form of this is the on-call runbook. A single SQL server has one entry: the server is down, everything is down. Here there are four entries and three of them are degradations rather than outages — which means three of them can wait until business hours.</a:t>
             </a:r>
             <a:endParaRPr lang="en-US" dirty="0"/>
           </a:p>
@@ -4148,7 +4125,9 @@
               <a:rPr lang="en-US" dirty="0"/>
               <a:t>Reads are served by the peer itself, from caches and from storage. They are parallel and independent of the transactor — a peer whose transactor is dead still answers queries.
 Writes are serialised through one process. That is what buys you ACID transactions with no coordination protocol, and it is the reason the write path needs HA while the read path needs caching.
-Hold on to this diagram: Part II is the left arrow, Part III the right one, and Part IV shows that 'parallelism' names a different mechanism on each side.</a:t>
+Hold on to this diagram: Part II is the left arrow, Part III the right one, and Part IV shows that 'parallelism' names a different mechanism on each side.
+Why writes funnel, stated precisely: transaction functions, uniqueness and cardinality checks all run against the current value of the database, so the transactor has to know the exact predecessor of every transaction. That is a serial dependency in the semantics, not an implementation limit. What it buys is transactions with no two-phase commit, no consensus round and no lock manager, because there is nothing to coordinate. What it costs is a throughput ceiling and a component that needs HA.
+Why reads fan out: a database value is immutable, so any number of readers can hold any number of points in time with no coordination. Nothing one reader does can change what another sees.</a:t>
             </a:r>
             <a:endParaRPr lang="en-US" dirty="0"/>
           </a:p>
@@ -4237,7 +4216,8 @@
             <a:r>
               <a:rPr lang="en-US" dirty="0"/>
               <a:t>People reach for d/db-stats expecting a cache report. It is a database report: how many datoms exist, by attribute. It says nothing about what is resident in any cache.
-There is no peer API that reports cache occupancy. Cache behaviour is observed one of two ways: through the metrics callback (Part V), or by timing the same query twice and comparing. Both appear later in this class.</a:t>
+There is no peer API that reports cache occupancy. Cache behaviour is observed one of two ways: through the metrics callback (Part V), or by timing the same query twice and comparing. Both appear later in this class.
+The failure signature this prevents: we added a cache tier and db-stats did not change. It would not. db-stats counts datoms, and the datom count does not depend on caching. The measurements that would show the change are query timing and the memcached hit ratio in Part V.</a:t>
             </a:r>
             <a:endParaRPr lang="en-US" dirty="0"/>
           </a:p>
@@ -4736,7 +4716,7 @@
                 <a:ea typeface="Helvetica Neue" pitchFamily="34" charset="-122"/>
                 <a:cs typeface="Helvetica Neue" pitchFamily="34" charset="-120"/>
               </a:rPr>
-              <a:t>A 2-HOUR CLASS + A 45-MINUTE INCIDENT</a:t>
+              <a:t>A 2-HOUR CLASS</a:t>
             </a:r>
             <a:endParaRPr lang="en-US" sz="1300" dirty="0"/>
           </a:p>
@@ -16484,7 +16464,7 @@
         <p:spPr>
           <a:xfrm>
             <a:off x="548640" y="1325880"/>
-            <a:ext cx="3520440" cy="2286000"/>
+            <a:ext cx="5349240" cy="2286000"/>
           </a:xfrm>
           <a:prstGeom prst="roundRect">
             <a:avLst>
@@ -16506,7 +16486,7 @@
         <p:spPr>
           <a:xfrm>
             <a:off x="548640" y="1325880"/>
-            <a:ext cx="3520440" cy="384048"/>
+            <a:ext cx="5349240" cy="384048"/>
           </a:xfrm>
           <a:prstGeom prst="roundRect">
             <a:avLst>
@@ -16528,7 +16508,7 @@
         <p:spPr>
           <a:xfrm>
             <a:off x="749808" y="1325880"/>
-            <a:ext cx="3118104" cy="384048"/>
+            <a:ext cx="4946904" cy="384048"/>
           </a:xfrm>
           <a:prstGeom prst="rect">
             <a:avLst/>
@@ -16569,7 +16549,7 @@
         <p:spPr>
           <a:xfrm>
             <a:off x="777240" y="1874520"/>
-            <a:ext cx="3063240" cy="1554480"/>
+            <a:ext cx="4892040" cy="1554480"/>
           </a:xfrm>
           <a:prstGeom prst="rect">
             <a:avLst/>
@@ -16616,7 +16596,7 @@
                 <a:ea typeface="Helvetica Neue" pitchFamily="34" charset="-122"/>
                 <a:cs typeface="Helvetica Neue" pitchFamily="34" charset="-120"/>
               </a:rPr>
-              <a:t>Everything you need to follow</a:t>
+              <a:t>Everything needed to follow the class is</a:t>
             </a:r>
             <a:endParaRPr lang="en-US" sz="1350" dirty="0"/>
           </a:p>
@@ -16633,10 +16613,27 @@
                 <a:ea typeface="Helvetica Neue" pitchFamily="34" charset="-122"/>
                 <a:cs typeface="Helvetica Neue" pitchFamily="34" charset="-120"/>
               </a:rPr>
-              <a:t>the class is projected.</a:t>
+              <a:t>projected — the labs add measurement,</a:t>
             </a:r>
             <a:endParaRPr lang="en-US" sz="1350" dirty="0"/>
           </a:p>
+          <a:p>
+            <a:pPr indent="0" marL="0">
+              <a:buNone/>
+            </a:pPr>
+            <a:r>
+              <a:rPr lang="en-US" sz="1350" dirty="0">
+                <a:solidFill>
+                  <a:srgbClr val="6B5A44"/>
+                </a:solidFill>
+                <a:latin typeface="Helvetica Neue" pitchFamily="34" charset="0"/>
+                <a:ea typeface="Helvetica Neue" pitchFamily="34" charset="-122"/>
+                <a:cs typeface="Helvetica Neue" pitchFamily="34" charset="-120"/>
+              </a:rPr>
+              <a:t>not content.</a:t>
+            </a:r>
+            <a:endParaRPr lang="en-US" sz="1350" dirty="0"/>
+          </a:p>
         </p:txBody>
       </p:sp>
       <p:sp>
@@ -16647,8 +16644,8 @@
         </p:nvSpPr>
         <p:spPr>
           <a:xfrm>
-            <a:off x="4297680" y="1325880"/>
-            <a:ext cx="3520440" cy="2286000"/>
+            <a:off x="6263640" y="1325880"/>
+            <a:ext cx="5349240" cy="2286000"/>
           </a:xfrm>
           <a:prstGeom prst="roundRect">
             <a:avLst>
@@ -16669,8 +16666,8 @@
         </p:nvSpPr>
         <p:spPr>
           <a:xfrm>
-            <a:off x="4297680" y="1325880"/>
-            <a:ext cx="3520440" cy="384048"/>
+            <a:off x="6263640" y="1325880"/>
+            <a:ext cx="5349240" cy="384048"/>
           </a:xfrm>
           <a:prstGeom prst="roundRect">
             <a:avLst>
@@ -16691,8 +16688,8 @@
         </p:nvSpPr>
         <p:spPr>
           <a:xfrm>
-            <a:off x="4498848" y="1325880"/>
-            <a:ext cx="3118104" cy="384048"/>
+            <a:off x="6464808" y="1325880"/>
+            <a:ext cx="4946904" cy="384048"/>
           </a:xfrm>
           <a:prstGeom prst="rect">
             <a:avLst/>
@@ -16732,8 +16729,8 @@
         </p:nvSpPr>
         <p:spPr>
           <a:xfrm>
-            <a:off x="4526280" y="1874520"/>
-            <a:ext cx="3063240" cy="1554480"/>
+            <a:off x="6492240" y="1874520"/>
+            <a:ext cx="4892040" cy="1554480"/>
           </a:xfrm>
           <a:prstGeom prst="rect">
             <a:avLst/>
@@ -16757,7 +16754,7 @@
                 <a:ea typeface="Helvetica Neue" pitchFamily="34" charset="-122"/>
                 <a:cs typeface="Helvetica Neue" pitchFamily="34" charset="-120"/>
               </a:rPr>
-              <a:t>§0–§6, reached from the ⚑</a:t>
+              <a:t>§0–§6, reached from the ⚑ waypoint boxes.</a:t>
             </a:r>
             <a:endParaRPr lang="en-US" sz="1350" dirty="0"/>
           </a:p>
@@ -16765,6 +16762,12 @@
             <a:pPr indent="0" marL="0">
               <a:buNone/>
             </a:pPr>
+            <a:endParaRPr lang="en-US" sz="1350" dirty="0"/>
+          </a:p>
+          <a:p>
+            <a:pPr indent="0" marL="0">
+              <a:buNone/>
+            </a:pPr>
             <a:r>
               <a:rPr lang="en-US" sz="1350" dirty="0">
                 <a:solidFill>
@@ -16774,7 +16777,7 @@
                 <a:ea typeface="Helvetica Neue" pitchFamily="34" charset="-122"/>
                 <a:cs typeface="Helvetica Neue" pitchFamily="34" charset="-120"/>
               </a:rPr>
-              <a:t>waypoint boxes.</a:t>
+              <a:t>Loosely coupled: take one early, late,</a:t>
             </a:r>
             <a:endParaRPr lang="en-US" sz="1350" dirty="0"/>
           </a:p>
@@ -16782,42 +16785,19 @@
             <a:pPr indent="0" marL="0">
               <a:buNone/>
             </a:pPr>
+            <a:r>
+              <a:rPr lang="en-US" sz="1350" dirty="0">
+                <a:solidFill>
+                  <a:srgbClr val="6B5A44"/>
+                </a:solidFill>
+                <a:latin typeface="Helvetica Neue" pitchFamily="34" charset="0"/>
+                <a:ea typeface="Helvetica Neue" pitchFamily="34" charset="-122"/>
+                <a:cs typeface="Helvetica Neue" pitchFamily="34" charset="-120"/>
+              </a:rPr>
+              <a:t>or not at all.</a:t>
+            </a:r>
             <a:endParaRPr lang="en-US" sz="1350" dirty="0"/>
           </a:p>
-          <a:p>
-            <a:pPr indent="0" marL="0">
-              <a:buNone/>
-            </a:pPr>
-            <a:r>
-              <a:rPr lang="en-US" sz="1350" dirty="0">
-                <a:solidFill>
-                  <a:srgbClr val="6B5A44"/>
-                </a:solidFill>
-                <a:latin typeface="Helvetica Neue" pitchFamily="34" charset="0"/>
-                <a:ea typeface="Helvetica Neue" pitchFamily="34" charset="-122"/>
-                <a:cs typeface="Helvetica Neue" pitchFamily="34" charset="-120"/>
-              </a:rPr>
-              <a:t>Loosely coupled: take one early,</a:t>
-            </a:r>
-            <a:endParaRPr lang="en-US" sz="1350" dirty="0"/>
-          </a:p>
-          <a:p>
-            <a:pPr indent="0" marL="0">
-              <a:buNone/>
-            </a:pPr>
-            <a:r>
-              <a:rPr lang="en-US" sz="1350" dirty="0">
-                <a:solidFill>
-                  <a:srgbClr val="6B5A44"/>
-                </a:solidFill>
-                <a:latin typeface="Helvetica Neue" pitchFamily="34" charset="0"/>
-                <a:ea typeface="Helvetica Neue" pitchFamily="34" charset="-122"/>
-                <a:cs typeface="Helvetica Neue" pitchFamily="34" charset="-120"/>
-              </a:rPr>
-              <a:t>late, or not at all.</a:t>
-            </a:r>
-            <a:endParaRPr lang="en-US" sz="1350" dirty="0"/>
-          </a:p>
         </p:txBody>
       </p:sp>
       <p:sp>
@@ -16828,172 +16808,8 @@
         </p:nvSpPr>
         <p:spPr>
           <a:xfrm>
-            <a:off x="8046720" y="1325880"/>
-            <a:ext cx="3566160" cy="2286000"/>
-          </a:xfrm>
-          <a:prstGeom prst="roundRect">
-            <a:avLst>
-              <a:gd name="adj" fmla="val 3200"/>
-            </a:avLst>
-          </a:prstGeom>
-          <a:solidFill>
-            <a:srgbClr val="E6DFCE"/>
-          </a:solidFill>
-          <a:ln/>
-        </p:spPr>
-      </p:sp>
-      <p:sp>
-        <p:nvSpPr>
-          <p:cNvPr id="17" name="Shape 14"/>
-          <p:cNvSpPr/>
-          <p:nvPr/>
-        </p:nvSpPr>
-        <p:spPr>
-          <a:xfrm>
-            <a:off x="8046720" y="1325880"/>
-            <a:ext cx="3566160" cy="384048"/>
-          </a:xfrm>
-          <a:prstGeom prst="roundRect">
-            <a:avLst>
-              <a:gd name="adj" fmla="val 19048"/>
-            </a:avLst>
-          </a:prstGeom>
-          <a:solidFill>
-            <a:srgbClr val="DFD6C0"/>
-          </a:solidFill>
-          <a:ln/>
-        </p:spPr>
-      </p:sp>
-      <p:sp>
-        <p:nvSpPr>
-          <p:cNvPr id="18" name="Text 15"/>
-          <p:cNvSpPr/>
-          <p:nvPr/>
-        </p:nvSpPr>
-        <p:spPr>
-          <a:xfrm>
-            <a:off x="8247888" y="1325880"/>
-            <a:ext cx="3163824" cy="384048"/>
-          </a:xfrm>
-          <a:prstGeom prst="rect">
-            <a:avLst/>
-          </a:prstGeom>
-          <a:noFill/>
-          <a:ln/>
-        </p:spPr>
-        <p:txBody>
-          <a:bodyPr wrap="square" lIns="0" tIns="0" rIns="0" bIns="0" rtlCol="0" anchor="ctr">
-            <a:normAutofit/>
-          </a:bodyPr>
-          <a:lstStyle/>
-          <a:p>
-            <a:pPr indent="0" marL="0">
-              <a:buNone/>
-            </a:pPr>
-            <a:r>
-              <a:rPr lang="en-US" sz="1250" b="1" spc="100" kern="0" dirty="0">
-                <a:solidFill>
-                  <a:srgbClr val="A8864A"/>
-                </a:solidFill>
-                <a:latin typeface="Helvetica Neue" pitchFamily="34" charset="0"/>
-                <a:ea typeface="Helvetica Neue" pitchFamily="34" charset="-122"/>
-                <a:cs typeface="Helvetica Neue" pitchFamily="34" charset="-120"/>
-              </a:rPr>
-              <a:t>EXERCISE · exercises.clj</a:t>
-            </a:r>
-            <a:endParaRPr lang="en-US" sz="1250" dirty="0"/>
-          </a:p>
-        </p:txBody>
-      </p:sp>
-      <p:sp>
-        <p:nvSpPr>
-          <p:cNvPr id="19" name="Text 16"/>
-          <p:cNvSpPr/>
-          <p:nvPr/>
-        </p:nvSpPr>
-        <p:spPr>
-          <a:xfrm>
-            <a:off x="8275320" y="1874520"/>
-            <a:ext cx="3108960" cy="1554480"/>
-          </a:xfrm>
-          <a:prstGeom prst="rect">
-            <a:avLst/>
-          </a:prstGeom>
-          <a:noFill/>
-          <a:ln/>
-        </p:spPr>
-        <p:txBody>
-          <a:bodyPr wrap="square" lIns="0" tIns="0" rIns="0" bIns="0" rtlCol="0" anchor="t"/>
-          <a:lstStyle/>
-          <a:p>
-            <a:pPr indent="0" marL="0">
-              <a:buNone/>
-            </a:pPr>
-            <a:r>
-              <a:rPr lang="en-US" sz="1350" dirty="0">
-                <a:solidFill>
-                  <a:srgbClr val="6B5A44"/>
-                </a:solidFill>
-                <a:latin typeface="Helvetica Neue" pitchFamily="34" charset="0"/>
-                <a:ea typeface="Helvetica Neue" pitchFamily="34" charset="-122"/>
-                <a:cs typeface="Helvetica Neue" pitchFamily="34" charset="-120"/>
-              </a:rPr>
-              <a:t>The Incident, E1–E4.</a:t>
-            </a:r>
-            <a:endParaRPr lang="en-US" sz="1350" dirty="0"/>
-          </a:p>
-          <a:p>
-            <a:pPr indent="0" marL="0">
-              <a:buNone/>
-            </a:pPr>
-            <a:endParaRPr lang="en-US" sz="1350" dirty="0"/>
-          </a:p>
-          <a:p>
-            <a:pPr indent="0" marL="0">
-              <a:buNone/>
-            </a:pPr>
-            <a:r>
-              <a:rPr lang="en-US" sz="1350" dirty="0">
-                <a:solidFill>
-                  <a:srgbClr val="6B5A44"/>
-                </a:solidFill>
-                <a:latin typeface="Helvetica Neue" pitchFamily="34" charset="0"/>
-                <a:ea typeface="Helvetica Neue" pitchFamily="34" charset="-122"/>
-                <a:cs typeface="Helvetica Neue" pitchFamily="34" charset="-120"/>
-              </a:rPr>
-              <a:t>After the break, ~45 min,</a:t>
-            </a:r>
-            <a:endParaRPr lang="en-US" sz="1350" dirty="0"/>
-          </a:p>
-          <a:p>
-            <a:pPr indent="0" marL="0">
-              <a:buNone/>
-            </a:pPr>
-            <a:r>
-              <a:rPr lang="en-US" sz="1350" dirty="0">
-                <a:solidFill>
-                  <a:srgbClr val="6B5A44"/>
-                </a:solidFill>
-                <a:latin typeface="Helvetica Neue" pitchFamily="34" charset="0"/>
-                <a:ea typeface="Helvetica Neue" pitchFamily="34" charset="-122"/>
-                <a:cs typeface="Helvetica Neue" pitchFamily="34" charset="-120"/>
-              </a:rPr>
-              <a:t>fill-the-gaps with solutions.</a:t>
-            </a:r>
-            <a:endParaRPr lang="en-US" sz="1350" dirty="0"/>
-          </a:p>
-        </p:txBody>
-      </p:sp>
-      <p:sp>
-        <p:nvSpPr>
-          <p:cNvPr id="20" name="Shape 17"/>
-          <p:cNvSpPr/>
-          <p:nvPr/>
-        </p:nvSpPr>
-        <p:spPr>
-          <a:xfrm>
             <a:off x="548640" y="3886200"/>
-            <a:ext cx="5440680" cy="960120"/>
+            <a:ext cx="5349240" cy="960120"/>
           </a:xfrm>
           <a:prstGeom prst="roundRect">
             <a:avLst>
@@ -17008,7 +16824,7 @@
       </p:sp>
       <p:sp>
         <p:nvSpPr>
-          <p:cNvPr id="21" name="Shape 18"/>
+          <p:cNvPr id="17" name="Shape 14"/>
           <p:cNvSpPr/>
           <p:nvPr/>
         </p:nvSpPr>
@@ -17030,7 +16846,7 @@
       </p:sp>
       <p:sp>
         <p:nvSpPr>
-          <p:cNvPr id="22" name="Text 19"/>
+          <p:cNvPr id="18" name="Text 15"/>
           <p:cNvSpPr/>
           <p:nvPr/>
         </p:nvSpPr>
@@ -17069,7 +16885,7 @@
       </p:sp>
       <p:sp>
         <p:nvSpPr>
-          <p:cNvPr id="23" name="Text 20"/>
+          <p:cNvPr id="19" name="Text 16"/>
           <p:cNvSpPr/>
           <p:nvPr/>
         </p:nvSpPr>
@@ -17110,14 +16926,14 @@
       </p:sp>
       <p:sp>
         <p:nvSpPr>
-          <p:cNvPr id="24" name="Shape 21"/>
-          <p:cNvSpPr/>
-          <p:nvPr/>
-        </p:nvSpPr>
-        <p:spPr>
-          <a:xfrm>
-            <a:off x="6172200" y="3886200"/>
-            <a:ext cx="5440680" cy="960120"/>
+          <p:cNvPr id="20" name="Shape 17"/>
+          <p:cNvSpPr/>
+          <p:nvPr/>
+        </p:nvSpPr>
+        <p:spPr>
+          <a:xfrm>
+            <a:off x="6263640" y="3886200"/>
+            <a:ext cx="5349240" cy="960120"/>
           </a:xfrm>
           <a:prstGeom prst="roundRect">
             <a:avLst>
@@ -17132,13 +16948,13 @@
       </p:sp>
       <p:sp>
         <p:nvSpPr>
-          <p:cNvPr id="25" name="Shape 22"/>
-          <p:cNvSpPr/>
-          <p:nvPr/>
-        </p:nvSpPr>
-        <p:spPr>
-          <a:xfrm>
-            <a:off x="6400800" y="4114800"/>
+          <p:cNvPr id="21" name="Shape 18"/>
+          <p:cNvSpPr/>
+          <p:nvPr/>
+        </p:nvSpPr>
+        <p:spPr>
+          <a:xfrm>
+            <a:off x="6492240" y="4114800"/>
             <a:ext cx="777240" cy="292608"/>
           </a:xfrm>
           <a:prstGeom prst="roundRect">
@@ -17154,13 +16970,13 @@
       </p:sp>
       <p:sp>
         <p:nvSpPr>
-          <p:cNvPr id="26" name="Text 23"/>
-          <p:cNvSpPr/>
-          <p:nvPr/>
-        </p:nvSpPr>
-        <p:spPr>
-          <a:xfrm>
-            <a:off x="6400800" y="4114800"/>
+          <p:cNvPr id="22" name="Text 19"/>
+          <p:cNvSpPr/>
+          <p:nvPr/>
+        </p:nvSpPr>
+        <p:spPr>
+          <a:xfrm>
+            <a:off x="6492240" y="4114800"/>
             <a:ext cx="777240" cy="292608"/>
           </a:xfrm>
           <a:prstGeom prst="rect">
@@ -17193,13 +17009,13 @@
       </p:sp>
       <p:sp>
         <p:nvSpPr>
-          <p:cNvPr id="27" name="Text 24"/>
-          <p:cNvSpPr/>
-          <p:nvPr/>
-        </p:nvSpPr>
-        <p:spPr>
-          <a:xfrm>
-            <a:off x="7406640" y="4114800"/>
+          <p:cNvPr id="23" name="Text 20"/>
+          <p:cNvSpPr/>
+          <p:nvPr/>
+        </p:nvSpPr>
+        <p:spPr>
+          <a:xfrm>
+            <a:off x="7498080" y="4114800"/>
             <a:ext cx="4023360" cy="548640"/>
           </a:xfrm>
           <a:prstGeom prst="rect">
@@ -17234,7 +17050,7 @@
       </p:sp>
       <p:sp>
         <p:nvSpPr>
-          <p:cNvPr id="28" name="Shape 25"/>
+          <p:cNvPr id="24" name="Shape 21"/>
           <p:cNvSpPr/>
           <p:nvPr/>
         </p:nvSpPr>
@@ -17254,7 +17070,7 @@
       </p:sp>
       <p:sp>
         <p:nvSpPr>
-          <p:cNvPr id="29" name="Text 26"/>
+          <p:cNvPr id="25" name="Text 22"/>
           <p:cNvSpPr/>
           <p:nvPr/>
         </p:nvSpPr>
@@ -17295,7 +17111,7 @@
       </p:sp>
       <p:sp>
         <p:nvSpPr>
-          <p:cNvPr id="30" name="Text 27"/>
+          <p:cNvPr id="26" name="Text 23"/>
           <p:cNvSpPr/>
           <p:nvPr/>
         </p:nvSpPr>
@@ -17328,7 +17144,7 @@
                 <a:ea typeface="Helvetica Neue" pitchFamily="34" charset="-122"/>
                 <a:cs typeface="Helvetica Neue" pitchFamily="34" charset="-120"/>
               </a:rPr>
-              <a:t>Setup: clj -M:repl covers every [MEM] lab and the whole exercise.</a:t>
+              <a:t>Setup: clj -M:repl covers every [MEM] lab.</a:t>
             </a:r>
             <a:endParaRPr lang="en-US" sz="1250" dirty="0"/>
           </a:p>
@@ -27875,128 +27691,7 @@
         </p:nvSpPr>
         <p:spPr>
           <a:xfrm>
-            <a:off x="731520" y="5340096"/>
-            <a:ext cx="914400" cy="512064"/>
-          </a:xfrm>
-          <a:prstGeom prst="rect">
-            <a:avLst/>
-          </a:prstGeom>
-          <a:noFill/>
-          <a:ln/>
-        </p:spPr>
-        <p:txBody>
-          <a:bodyPr wrap="square" lIns="0" tIns="0" rIns="0" bIns="0" rtlCol="0" anchor="ctr"/>
-          <a:lstStyle/>
-          <a:p>
-            <a:pPr indent="0" marL="0">
-              <a:buNone/>
-            </a:pPr>
-            <a:r>
-              <a:rPr lang="en-US" sz="1400" dirty="0">
-                <a:solidFill>
-                  <a:srgbClr val="9E4227"/>
-                </a:solidFill>
-                <a:latin typeface="Courier New" pitchFamily="34" charset="0"/>
-                <a:ea typeface="Courier New" pitchFamily="34" charset="-122"/>
-                <a:cs typeface="Courier New" pitchFamily="34" charset="-120"/>
-              </a:rPr>
-              <a:t>2:00</a:t>
-            </a:r>
-            <a:endParaRPr lang="en-US" sz="1400" dirty="0"/>
-          </a:p>
-        </p:txBody>
-      </p:sp>
-      <p:sp>
-        <p:nvSpPr>
-          <p:cNvPr id="34" name="Text 31"/>
-          <p:cNvSpPr/>
-          <p:nvPr/>
-        </p:nvSpPr>
-        <p:spPr>
-          <a:xfrm>
-            <a:off x="1828800" y="5340096"/>
-            <a:ext cx="4754880" cy="512064"/>
-          </a:xfrm>
-          <a:prstGeom prst="rect">
-            <a:avLst/>
-          </a:prstGeom>
-          <a:noFill/>
-          <a:ln/>
-        </p:spPr>
-        <p:txBody>
-          <a:bodyPr wrap="square" lIns="0" tIns="0" rIns="0" bIns="0" rtlCol="0" anchor="ctr">
-            <a:normAutofit/>
-          </a:bodyPr>
-          <a:lstStyle/>
-          <a:p>
-            <a:pPr indent="0" marL="0">
-              <a:buNone/>
-            </a:pPr>
-            <a:r>
-              <a:rPr lang="en-US" sz="1550" b="1" dirty="0">
-                <a:solidFill>
-                  <a:srgbClr val="3A2C1A"/>
-                </a:solidFill>
-                <a:latin typeface="Helvetica Neue" pitchFamily="34" charset="0"/>
-                <a:ea typeface="Helvetica Neue" pitchFamily="34" charset="-122"/>
-                <a:cs typeface="Helvetica Neue" pitchFamily="34" charset="-120"/>
-              </a:rPr>
-              <a:t>→ The Incident (E1–E4)</a:t>
-            </a:r>
-            <a:endParaRPr lang="en-US" sz="1550" dirty="0"/>
-          </a:p>
-        </p:txBody>
-      </p:sp>
-      <p:sp>
-        <p:nvSpPr>
-          <p:cNvPr id="35" name="Text 32"/>
-          <p:cNvSpPr/>
-          <p:nvPr/>
-        </p:nvSpPr>
-        <p:spPr>
-          <a:xfrm>
-            <a:off x="6675120" y="5340096"/>
-            <a:ext cx="4754880" cy="512064"/>
-          </a:xfrm>
-          <a:prstGeom prst="rect">
-            <a:avLst/>
-          </a:prstGeom>
-          <a:noFill/>
-          <a:ln/>
-        </p:spPr>
-        <p:txBody>
-          <a:bodyPr wrap="square" lIns="0" tIns="0" rIns="0" bIns="0" rtlCol="0" anchor="ctr">
-            <a:normAutofit/>
-          </a:bodyPr>
-          <a:lstStyle/>
-          <a:p>
-            <a:pPr indent="0" marL="0">
-              <a:buNone/>
-            </a:pPr>
-            <a:r>
-              <a:rPr lang="en-US" sz="1400" dirty="0">
-                <a:solidFill>
-                  <a:srgbClr val="6B5A44"/>
-                </a:solidFill>
-                <a:latin typeface="Helvetica Neue" pitchFamily="34" charset="0"/>
-                <a:ea typeface="Helvetica Neue" pitchFamily="34" charset="-122"/>
-                <a:cs typeface="Helvetica Neue" pitchFamily="34" charset="-120"/>
-              </a:rPr>
-              <a:t>~45 min, continues past the hour</a:t>
-            </a:r>
-            <a:endParaRPr lang="en-US" sz="1400" dirty="0"/>
-          </a:p>
-        </p:txBody>
-      </p:sp>
-      <p:sp>
-        <p:nvSpPr>
-          <p:cNvPr id="36" name="Text 33"/>
-          <p:cNvSpPr/>
-          <p:nvPr/>
-        </p:nvSpPr>
-        <p:spPr>
-          <a:xfrm>
-            <a:off x="548640" y="6035040"/>
+            <a:off x="548640" y="5486400"/>
             <a:ext cx="11064240" cy="365760"/>
           </a:xfrm>
           <a:prstGeom prst="rect">
@@ -28023,7 +27718,7 @@
                 <a:ea typeface="Helvetica Neue" pitchFamily="34" charset="-122"/>
                 <a:cs typeface="Helvetica Neue" pitchFamily="34" charset="-120"/>
               </a:rPr>
-              <a:t>Setup: infra/HA.md for the live Part II lab. Otherwise clj -M:repl covers the [MEM] labs and the whole exercise.</a:t>
+              <a:t>Setup: infra/HA.md for the live Part II lab. Otherwise clj -M:repl covers every [MEM] lab.</a:t>
             </a:r>
             <a:endParaRPr lang="en-US" sz="1250" dirty="0"/>
           </a:p>
@@ -38832,1197 +38527,6 @@
             <a:avLst/>
           </a:prstGeom>
           <a:solidFill>
-            <a:srgbClr val="2C2416"/>
-          </a:solidFill>
-          <a:ln/>
-        </p:spPr>
-      </p:sp>
-      <p:sp>
-        <p:nvSpPr>
-          <p:cNvPr id="3" name="Text 1"/>
-          <p:cNvSpPr/>
-          <p:nvPr/>
-        </p:nvSpPr>
-        <p:spPr>
-          <a:xfrm>
-            <a:off x="731520" y="548640"/>
-            <a:ext cx="10515600" cy="320040"/>
-          </a:xfrm>
-          <a:prstGeom prst="rect">
-            <a:avLst/>
-          </a:prstGeom>
-          <a:noFill/>
-          <a:ln/>
-        </p:spPr>
-        <p:txBody>
-          <a:bodyPr wrap="square" lIns="0" tIns="0" rIns="0" bIns="0" rtlCol="0" anchor="t"/>
-          <a:lstStyle/>
-          <a:p>
-            <a:pPr indent="0" marL="0">
-              <a:buNone/>
-            </a:pPr>
-            <a:r>
-              <a:rPr lang="en-US" sz="1200" spc="300" kern="0" dirty="0">
-                <a:solidFill>
-                  <a:srgbClr val="C6A46A"/>
-                </a:solidFill>
-                <a:latin typeface="Helvetica Neue" pitchFamily="34" charset="0"/>
-                <a:ea typeface="Helvetica Neue" pitchFamily="34" charset="-122"/>
-                <a:cs typeface="Helvetica Neue" pitchFamily="34" charset="-120"/>
-              </a:rPr>
-              <a:t>AFTER THE BREAK  ·  ~45 MINUTES</a:t>
-            </a:r>
-            <a:endParaRPr lang="en-US" sz="1200" dirty="0"/>
-          </a:p>
-        </p:txBody>
-      </p:sp>
-      <p:sp>
-        <p:nvSpPr>
-          <p:cNvPr id="4" name="Text 2"/>
-          <p:cNvSpPr/>
-          <p:nvPr/>
-        </p:nvSpPr>
-        <p:spPr>
-          <a:xfrm>
-            <a:off x="731520" y="914400"/>
-            <a:ext cx="10515600" cy="777240"/>
-          </a:xfrm>
-          <a:prstGeom prst="rect">
-            <a:avLst/>
-          </a:prstGeom>
-          <a:noFill/>
-          <a:ln/>
-        </p:spPr>
-        <p:txBody>
-          <a:bodyPr wrap="square" lIns="0" tIns="0" rIns="0" bIns="0" rtlCol="0" anchor="t"/>
-          <a:lstStyle/>
-          <a:p>
-            <a:pPr indent="0" marL="0">
-              <a:buNone/>
-            </a:pPr>
-            <a:r>
-              <a:rPr lang="en-US" sz="3600" dirty="0">
-                <a:solidFill>
-                  <a:srgbClr val="FCFAF4"/>
-                </a:solidFill>
-                <a:latin typeface="Georgia" pitchFamily="34" charset="0"/>
-                <a:ea typeface="Georgia" pitchFamily="34" charset="-122"/>
-                <a:cs typeface="Georgia" pitchFamily="34" charset="-120"/>
-              </a:rPr>
-              <a:t>→ The Incident</a:t>
-            </a:r>
-            <a:endParaRPr lang="en-US" sz="3600" dirty="0"/>
-          </a:p>
-        </p:txBody>
-      </p:sp>
-      <p:sp>
-        <p:nvSpPr>
-          <p:cNvPr id="5" name="Text 3"/>
-          <p:cNvSpPr/>
-          <p:nvPr/>
-        </p:nvSpPr>
-        <p:spPr>
-          <a:xfrm>
-            <a:off x="731520" y="1737360"/>
-            <a:ext cx="10515600" cy="731520"/>
-          </a:xfrm>
-          <a:prstGeom prst="rect">
-            <a:avLst/>
-          </a:prstGeom>
-          <a:noFill/>
-          <a:ln/>
-        </p:spPr>
-        <p:txBody>
-          <a:bodyPr wrap="square" lIns="0" tIns="0" rIns="0" bIns="0" rtlCol="0" anchor="t"/>
-          <a:lstStyle/>
-          <a:p>
-            <a:pPr indent="0" marL="0">
-              <a:buNone/>
-            </a:pPr>
-            <a:r>
-              <a:rPr lang="en-US" sz="1600" dirty="0">
-                <a:solidFill>
-                  <a:srgbClr val="C9BDA4"/>
-                </a:solidFill>
-                <a:latin typeface="Helvetica Neue" pitchFamily="34" charset="0"/>
-                <a:ea typeface="Helvetica Neue" pitchFamily="34" charset="-122"/>
-                <a:cs typeface="Helvetica Neue" pitchFamily="34" charset="-120"/>
-              </a:rPr>
-              <a:t>The readings service was healthy at 08:00 and unusable at 09:10.</a:t>
-            </a:r>
-            <a:endParaRPr lang="en-US" sz="1600" dirty="0"/>
-          </a:p>
-          <a:p>
-            <a:pPr indent="0" marL="0">
-              <a:buNone/>
-            </a:pPr>
-            <a:r>
-              <a:rPr lang="en-US" sz="1600" dirty="0">
-                <a:solidFill>
-                  <a:srgbClr val="C9BDA4"/>
-                </a:solidFill>
-                <a:latin typeface="Helvetica Neue" pitchFamily="34" charset="0"/>
-                <a:ea typeface="Helvetica Neue" pitchFamily="34" charset="-122"/>
-                <a:cs typeface="Helvetica Neue" pitchFamily="34" charset="-120"/>
-              </a:rPr>
-              <a:t>The database and the REPL are the available evidence.</a:t>
-            </a:r>
-            <a:endParaRPr lang="en-US" sz="1600" dirty="0"/>
-          </a:p>
-        </p:txBody>
-      </p:sp>
-      <p:sp>
-        <p:nvSpPr>
-          <p:cNvPr id="6" name="Shape 4"/>
-          <p:cNvSpPr/>
-          <p:nvPr/>
-        </p:nvSpPr>
-        <p:spPr>
-          <a:xfrm>
-            <a:off x="731520" y="2606040"/>
-            <a:ext cx="5120640" cy="1051560"/>
-          </a:xfrm>
-          <a:prstGeom prst="roundRect">
-            <a:avLst>
-              <a:gd name="adj" fmla="val 6957"/>
-            </a:avLst>
-          </a:prstGeom>
-          <a:solidFill>
-            <a:srgbClr val="3B3220"/>
-          </a:solidFill>
-          <a:ln/>
-        </p:spPr>
-      </p:sp>
-      <p:sp>
-        <p:nvSpPr>
-          <p:cNvPr id="7" name="Text 5"/>
-          <p:cNvSpPr/>
-          <p:nvPr/>
-        </p:nvSpPr>
-        <p:spPr>
-          <a:xfrm>
-            <a:off x="914400" y="2697480"/>
-            <a:ext cx="4754880" cy="868680"/>
-          </a:xfrm>
-          <a:prstGeom prst="rect">
-            <a:avLst/>
-          </a:prstGeom>
-          <a:noFill/>
-          <a:ln/>
-        </p:spPr>
-        <p:txBody>
-          <a:bodyPr wrap="square" lIns="0" tIns="0" rIns="0" bIns="0" rtlCol="0" anchor="t"/>
-          <a:lstStyle/>
-          <a:p>
-            <a:pPr indent="0" marL="0">
-              <a:buNone/>
-            </a:pPr>
-            <a:r>
-              <a:rPr lang="en-US" sz="1250" dirty="0">
-                <a:solidFill>
-                  <a:srgbClr val="C6A46A"/>
-                </a:solidFill>
-                <a:latin typeface="Courier New" pitchFamily="34" charset="0"/>
-                <a:ea typeface="Courier New" pitchFamily="34" charset="-122"/>
-                <a:cs typeface="Courier New" pitchFamily="34" charset="-120"/>
-              </a:rPr>
-              <a:t>clj -M:repl</a:t>
-            </a:r>
-            <a:endParaRPr lang="en-US" sz="1250" dirty="0"/>
-          </a:p>
-          <a:p>
-            <a:pPr indent="0" marL="0">
-              <a:buNone/>
-            </a:pPr>
-            <a:r>
-              <a:rPr lang="en-US" sz="1250" dirty="0">
-                <a:solidFill>
-                  <a:srgbClr val="C6A46A"/>
-                </a:solidFill>
-                <a:latin typeface="Courier New" pitchFamily="34" charset="0"/>
-                <a:ea typeface="Courier New" pitchFamily="34" charset="-122"/>
-                <a:cs typeface="Courier New" pitchFamily="34" charset="-120"/>
-              </a:rPr>
-              <a:t>(require 'datomic-ops.exercises)</a:t>
-            </a:r>
-            <a:endParaRPr lang="en-US" sz="1250" dirty="0"/>
-          </a:p>
-          <a:p>
-            <a:pPr indent="0" marL="0">
-              <a:buNone/>
-            </a:pPr>
-            <a:r>
-              <a:rPr lang="en-US" sz="1250" dirty="0">
-                <a:solidFill>
-                  <a:srgbClr val="C6A46A"/>
-                </a:solidFill>
-                <a:latin typeface="Courier New" pitchFamily="34" charset="0"/>
-                <a:ea typeface="Courier New" pitchFamily="34" charset="-122"/>
-                <a:cs typeface="Courier New" pitchFamily="34" charset="-120"/>
-              </a:rPr>
-              <a:t>(datomic-ops.exercises/start!)</a:t>
-            </a:r>
-            <a:endParaRPr lang="en-US" sz="1250" dirty="0"/>
-          </a:p>
-        </p:txBody>
-      </p:sp>
-      <p:sp>
-        <p:nvSpPr>
-          <p:cNvPr id="8" name="Text 6"/>
-          <p:cNvSpPr/>
-          <p:nvPr/>
-        </p:nvSpPr>
-        <p:spPr>
-          <a:xfrm>
-            <a:off x="6035040" y="2971800"/>
-            <a:ext cx="5394960" cy="365760"/>
-          </a:xfrm>
-          <a:prstGeom prst="rect">
-            <a:avLst/>
-          </a:prstGeom>
-          <a:noFill/>
-          <a:ln/>
-        </p:spPr>
-        <p:txBody>
-          <a:bodyPr wrap="square" lIns="0" tIns="0" rIns="0" bIns="0" rtlCol="0" anchor="t"/>
-          <a:lstStyle/>
-          <a:p>
-            <a:pPr indent="0" marL="0">
-              <a:buNone/>
-            </a:pPr>
-            <a:r>
-              <a:rPr lang="en-US" sz="1250" dirty="0">
-                <a:solidFill>
-                  <a:srgbClr val="C9BDA4"/>
-                </a:solidFill>
-                <a:latin typeface="Courier New" pitchFamily="34" charset="0"/>
-                <a:ea typeface="Courier New" pitchFamily="34" charset="-122"/>
-                <a:cs typeface="Courier New" pitchFamily="34" charset="-120"/>
-              </a:rPr>
-              <a:t>;; =&gt; [:incident :ready :basis-t 61013]</a:t>
-            </a:r>
-            <a:endParaRPr lang="en-US" sz="1250" dirty="0"/>
-          </a:p>
-        </p:txBody>
-      </p:sp>
-      <p:sp>
-        <p:nvSpPr>
-          <p:cNvPr id="9" name="Shape 7"/>
-          <p:cNvSpPr/>
-          <p:nvPr/>
-        </p:nvSpPr>
-        <p:spPr>
-          <a:xfrm>
-            <a:off x="731520" y="3886200"/>
-            <a:ext cx="2560320" cy="1691640"/>
-          </a:xfrm>
-          <a:prstGeom prst="roundRect">
-            <a:avLst>
-              <a:gd name="adj" fmla="val 4324"/>
-            </a:avLst>
-          </a:prstGeom>
-          <a:solidFill>
-            <a:srgbClr val="3B3220"/>
-          </a:solidFill>
-          <a:ln/>
-        </p:spPr>
-      </p:sp>
-      <p:sp>
-        <p:nvSpPr>
-          <p:cNvPr id="10" name="Shape 8"/>
-          <p:cNvSpPr/>
-          <p:nvPr/>
-        </p:nvSpPr>
-        <p:spPr>
-          <a:xfrm>
-            <a:off x="731520" y="3886200"/>
-            <a:ext cx="2560320" cy="91440"/>
-          </a:xfrm>
-          <a:prstGeom prst="rect">
-            <a:avLst/>
-          </a:prstGeom>
-          <a:solidFill>
-            <a:srgbClr val="A8864A"/>
-          </a:solidFill>
-          <a:ln/>
-        </p:spPr>
-      </p:sp>
-      <p:sp>
-        <p:nvSpPr>
-          <p:cNvPr id="11" name="Text 9"/>
-          <p:cNvSpPr/>
-          <p:nvPr/>
-        </p:nvSpPr>
-        <p:spPr>
-          <a:xfrm>
-            <a:off x="932688" y="4069080"/>
-            <a:ext cx="2194560" cy="365760"/>
-          </a:xfrm>
-          <a:prstGeom prst="rect">
-            <a:avLst/>
-          </a:prstGeom>
-          <a:noFill/>
-          <a:ln/>
-        </p:spPr>
-        <p:txBody>
-          <a:bodyPr wrap="square" lIns="0" tIns="0" rIns="0" bIns="0" rtlCol="0" anchor="t"/>
-          <a:lstStyle/>
-          <a:p>
-            <a:pPr indent="0" marL="0">
-              <a:buNone/>
-            </a:pPr>
-            <a:r>
-              <a:rPr lang="en-US" sz="2000" dirty="0">
-                <a:solidFill>
-                  <a:srgbClr val="C6A46A"/>
-                </a:solidFill>
-                <a:latin typeface="Georgia" pitchFamily="34" charset="0"/>
-                <a:ea typeface="Georgia" pitchFamily="34" charset="-122"/>
-                <a:cs typeface="Georgia" pitchFamily="34" charset="-120"/>
-              </a:rPr>
-              <a:t>E1</a:t>
-            </a:r>
-            <a:endParaRPr lang="en-US" sz="2000" dirty="0"/>
-          </a:p>
-        </p:txBody>
-      </p:sp>
-      <p:sp>
-        <p:nvSpPr>
-          <p:cNvPr id="12" name="Text 10"/>
-          <p:cNvSpPr/>
-          <p:nvPr/>
-        </p:nvSpPr>
-        <p:spPr>
-          <a:xfrm>
-            <a:off x="932688" y="4069080"/>
-            <a:ext cx="2194560" cy="365760"/>
-          </a:xfrm>
-          <a:prstGeom prst="rect">
-            <a:avLst/>
-          </a:prstGeom>
-          <a:noFill/>
-          <a:ln/>
-        </p:spPr>
-        <p:txBody>
-          <a:bodyPr wrap="square" lIns="0" tIns="0" rIns="0" bIns="0" rtlCol="0" anchor="t"/>
-          <a:lstStyle/>
-          <a:p>
-            <a:pPr algn="r" indent="0" marL="0">
-              <a:buNone/>
-            </a:pPr>
-            <a:r>
-              <a:rPr lang="en-US" sz="1150" dirty="0">
-                <a:solidFill>
-                  <a:srgbClr val="9A8A72"/>
-                </a:solidFill>
-                <a:latin typeface="Helvetica Neue" pitchFamily="34" charset="0"/>
-                <a:ea typeface="Helvetica Neue" pitchFamily="34" charset="-122"/>
-                <a:cs typeface="Helvetica Neue" pitchFamily="34" charset="-120"/>
-              </a:rPr>
-              <a:t>~8 min</a:t>
-            </a:r>
-            <a:endParaRPr lang="en-US" sz="1150" dirty="0"/>
-          </a:p>
-        </p:txBody>
-      </p:sp>
-      <p:sp>
-        <p:nvSpPr>
-          <p:cNvPr id="13" name="Text 11"/>
-          <p:cNvSpPr/>
-          <p:nvPr/>
-        </p:nvSpPr>
-        <p:spPr>
-          <a:xfrm>
-            <a:off x="932688" y="4526280"/>
-            <a:ext cx="2194560" cy="411480"/>
-          </a:xfrm>
-          <a:prstGeom prst="rect">
-            <a:avLst/>
-          </a:prstGeom>
-          <a:noFill/>
-          <a:ln/>
-        </p:spPr>
-        <p:txBody>
-          <a:bodyPr wrap="square" lIns="0" tIns="0" rIns="0" bIns="0" rtlCol="0" anchor="t">
-            <a:normAutofit/>
-          </a:bodyPr>
-          <a:lstStyle/>
-          <a:p>
-            <a:pPr indent="0" marL="0">
-              <a:buNone/>
-            </a:pPr>
-            <a:r>
-              <a:rPr lang="en-US" sz="1400" b="1" dirty="0">
-                <a:solidFill>
-                  <a:srgbClr val="FCFAF4"/>
-                </a:solidFill>
-                <a:latin typeface="Helvetica Neue" pitchFamily="34" charset="0"/>
-                <a:ea typeface="Helvetica Neue" pitchFamily="34" charset="-122"/>
-                <a:cs typeface="Helvetica Neue" pitchFamily="34" charset="-120"/>
-              </a:rPr>
-              <a:t>Read the evidence</a:t>
-            </a:r>
-            <a:endParaRPr lang="en-US" sz="1400" dirty="0"/>
-          </a:p>
-        </p:txBody>
-      </p:sp>
-      <p:sp>
-        <p:nvSpPr>
-          <p:cNvPr id="14" name="Text 12"/>
-          <p:cNvSpPr/>
-          <p:nvPr/>
-        </p:nvSpPr>
-        <p:spPr>
-          <a:xfrm>
-            <a:off x="932688" y="4956048"/>
-            <a:ext cx="2194560" cy="548640"/>
-          </a:xfrm>
-          <a:prstGeom prst="rect">
-            <a:avLst/>
-          </a:prstGeom>
-          <a:noFill/>
-          <a:ln/>
-        </p:spPr>
-        <p:txBody>
-          <a:bodyPr wrap="square" lIns="0" tIns="0" rIns="0" bIns="0" rtlCol="0" anchor="t"/>
-          <a:lstStyle/>
-          <a:p>
-            <a:pPr indent="0" marL="0">
-              <a:buNone/>
-            </a:pPr>
-            <a:r>
-              <a:rPr lang="en-US" sz="1150" dirty="0">
-                <a:solidFill>
-                  <a:srgbClr val="C9BDA4"/>
-                </a:solidFill>
-                <a:latin typeface="Helvetica Neue" pitchFamily="34" charset="0"/>
-                <a:ea typeface="Helvetica Neue" pitchFamily="34" charset="-122"/>
-                <a:cs typeface="Helvetica Neue" pitchFamily="34" charset="-120"/>
-              </a:rPr>
-              <a:t>the log as an audit trail</a:t>
-            </a:r>
-            <a:endParaRPr lang="en-US" sz="1150" dirty="0"/>
-          </a:p>
-        </p:txBody>
-      </p:sp>
-      <p:sp>
-        <p:nvSpPr>
-          <p:cNvPr id="15" name="Shape 13"/>
-          <p:cNvSpPr/>
-          <p:nvPr/>
-        </p:nvSpPr>
-        <p:spPr>
-          <a:xfrm>
-            <a:off x="3474720" y="3886200"/>
-            <a:ext cx="2560320" cy="1691640"/>
-          </a:xfrm>
-          <a:prstGeom prst="roundRect">
-            <a:avLst>
-              <a:gd name="adj" fmla="val 4324"/>
-            </a:avLst>
-          </a:prstGeom>
-          <a:solidFill>
-            <a:srgbClr val="3B3220"/>
-          </a:solidFill>
-          <a:ln/>
-        </p:spPr>
-      </p:sp>
-      <p:sp>
-        <p:nvSpPr>
-          <p:cNvPr id="16" name="Shape 14"/>
-          <p:cNvSpPr/>
-          <p:nvPr/>
-        </p:nvSpPr>
-        <p:spPr>
-          <a:xfrm>
-            <a:off x="3474720" y="3886200"/>
-            <a:ext cx="2560320" cy="91440"/>
-          </a:xfrm>
-          <a:prstGeom prst="rect">
-            <a:avLst/>
-          </a:prstGeom>
-          <a:solidFill>
-            <a:srgbClr val="A8864A"/>
-          </a:solidFill>
-          <a:ln/>
-        </p:spPr>
-      </p:sp>
-      <p:sp>
-        <p:nvSpPr>
-          <p:cNvPr id="17" name="Text 15"/>
-          <p:cNvSpPr/>
-          <p:nvPr/>
-        </p:nvSpPr>
-        <p:spPr>
-          <a:xfrm>
-            <a:off x="3675888" y="4069080"/>
-            <a:ext cx="2194560" cy="365760"/>
-          </a:xfrm>
-          <a:prstGeom prst="rect">
-            <a:avLst/>
-          </a:prstGeom>
-          <a:noFill/>
-          <a:ln/>
-        </p:spPr>
-        <p:txBody>
-          <a:bodyPr wrap="square" lIns="0" tIns="0" rIns="0" bIns="0" rtlCol="0" anchor="t"/>
-          <a:lstStyle/>
-          <a:p>
-            <a:pPr indent="0" marL="0">
-              <a:buNone/>
-            </a:pPr>
-            <a:r>
-              <a:rPr lang="en-US" sz="2000" dirty="0">
-                <a:solidFill>
-                  <a:srgbClr val="C6A46A"/>
-                </a:solidFill>
-                <a:latin typeface="Georgia" pitchFamily="34" charset="0"/>
-                <a:ea typeface="Georgia" pitchFamily="34" charset="-122"/>
-                <a:cs typeface="Georgia" pitchFamily="34" charset="-120"/>
-              </a:rPr>
-              <a:t>E2</a:t>
-            </a:r>
-            <a:endParaRPr lang="en-US" sz="2000" dirty="0"/>
-          </a:p>
-        </p:txBody>
-      </p:sp>
-      <p:sp>
-        <p:nvSpPr>
-          <p:cNvPr id="18" name="Text 16"/>
-          <p:cNvSpPr/>
-          <p:nvPr/>
-        </p:nvSpPr>
-        <p:spPr>
-          <a:xfrm>
-            <a:off x="3675888" y="4069080"/>
-            <a:ext cx="2194560" cy="365760"/>
-          </a:xfrm>
-          <a:prstGeom prst="rect">
-            <a:avLst/>
-          </a:prstGeom>
-          <a:noFill/>
-          <a:ln/>
-        </p:spPr>
-        <p:txBody>
-          <a:bodyPr wrap="square" lIns="0" tIns="0" rIns="0" bIns="0" rtlCol="0" anchor="t"/>
-          <a:lstStyle/>
-          <a:p>
-            <a:pPr algn="r" indent="0" marL="0">
-              <a:buNone/>
-            </a:pPr>
-            <a:r>
-              <a:rPr lang="en-US" sz="1150" dirty="0">
-                <a:solidFill>
-                  <a:srgbClr val="9A8A72"/>
-                </a:solidFill>
-                <a:latin typeface="Helvetica Neue" pitchFamily="34" charset="0"/>
-                <a:ea typeface="Helvetica Neue" pitchFamily="34" charset="-122"/>
-                <a:cs typeface="Helvetica Neue" pitchFamily="34" charset="-120"/>
-              </a:rPr>
-              <a:t>~10 min</a:t>
-            </a:r>
-            <a:endParaRPr lang="en-US" sz="1150" dirty="0"/>
-          </a:p>
-        </p:txBody>
-      </p:sp>
-      <p:sp>
-        <p:nvSpPr>
-          <p:cNvPr id="19" name="Text 17"/>
-          <p:cNvSpPr/>
-          <p:nvPr/>
-        </p:nvSpPr>
-        <p:spPr>
-          <a:xfrm>
-            <a:off x="3675888" y="4526280"/>
-            <a:ext cx="2194560" cy="411480"/>
-          </a:xfrm>
-          <a:prstGeom prst="rect">
-            <a:avLst/>
-          </a:prstGeom>
-          <a:noFill/>
-          <a:ln/>
-        </p:spPr>
-        <p:txBody>
-          <a:bodyPr wrap="square" lIns="0" tIns="0" rIns="0" bIns="0" rtlCol="0" anchor="t">
-            <a:normAutofit/>
-          </a:bodyPr>
-          <a:lstStyle/>
-          <a:p>
-            <a:pPr indent="0" marL="0">
-              <a:buNone/>
-            </a:pPr>
-            <a:r>
-              <a:rPr lang="en-US" sz="1400" b="1" dirty="0">
-                <a:solidFill>
-                  <a:srgbClr val="FCFAF4"/>
-                </a:solidFill>
-                <a:latin typeface="Helvetica Neue" pitchFamily="34" charset="0"/>
-                <a:ea typeface="Helvetica Neue" pitchFamily="34" charset="-122"/>
-                <a:cs typeface="Helvetica Neue" pitchFamily="34" charset="-120"/>
-              </a:rPr>
-              <a:t>Fix the writer</a:t>
-            </a:r>
-            <a:endParaRPr lang="en-US" sz="1400" dirty="0"/>
-          </a:p>
-        </p:txBody>
-      </p:sp>
-      <p:sp>
-        <p:nvSpPr>
-          <p:cNvPr id="20" name="Text 18"/>
-          <p:cNvSpPr/>
-          <p:nvPr/>
-        </p:nvSpPr>
-        <p:spPr>
-          <a:xfrm>
-            <a:off x="3675888" y="4956048"/>
-            <a:ext cx="2194560" cy="548640"/>
-          </a:xfrm>
-          <a:prstGeom prst="rect">
-            <a:avLst/>
-          </a:prstGeom>
-          <a:noFill/>
-          <a:ln/>
-        </p:spPr>
-        <p:txBody>
-          <a:bodyPr wrap="square" lIns="0" tIns="0" rIns="0" bIns="0" rtlCol="0" anchor="t"/>
-          <a:lstStyle/>
-          <a:p>
-            <a:pPr indent="0" marL="0">
-              <a:buNone/>
-            </a:pPr>
-            <a:r>
-              <a:rPr lang="en-US" sz="1150" dirty="0">
-                <a:solidFill>
-                  <a:srgbClr val="C9BDA4"/>
-                </a:solidFill>
-                <a:latin typeface="Helvetica Neue" pitchFamily="34" charset="0"/>
-                <a:ea typeface="Helvetica Neue" pitchFamily="34" charset="-122"/>
-                <a:cs typeface="Helvetica Neue" pitchFamily="34" charset="-120"/>
-              </a:rPr>
-              <a:t>transaction shape</a:t>
-            </a:r>
-            <a:endParaRPr lang="en-US" sz="1150" dirty="0"/>
-          </a:p>
-        </p:txBody>
-      </p:sp>
-      <p:sp>
-        <p:nvSpPr>
-          <p:cNvPr id="21" name="Shape 19"/>
-          <p:cNvSpPr/>
-          <p:nvPr/>
-        </p:nvSpPr>
-        <p:spPr>
-          <a:xfrm>
-            <a:off x="6217920" y="3886200"/>
-            <a:ext cx="2560320" cy="1691640"/>
-          </a:xfrm>
-          <a:prstGeom prst="roundRect">
-            <a:avLst>
-              <a:gd name="adj" fmla="val 4324"/>
-            </a:avLst>
-          </a:prstGeom>
-          <a:solidFill>
-            <a:srgbClr val="3B3220"/>
-          </a:solidFill>
-          <a:ln/>
-        </p:spPr>
-      </p:sp>
-      <p:sp>
-        <p:nvSpPr>
-          <p:cNvPr id="22" name="Shape 20"/>
-          <p:cNvSpPr/>
-          <p:nvPr/>
-        </p:nvSpPr>
-        <p:spPr>
-          <a:xfrm>
-            <a:off x="6217920" y="3886200"/>
-            <a:ext cx="2560320" cy="91440"/>
-          </a:xfrm>
-          <a:prstGeom prst="rect">
-            <a:avLst/>
-          </a:prstGeom>
-          <a:solidFill>
-            <a:srgbClr val="A8864A"/>
-          </a:solidFill>
-          <a:ln/>
-        </p:spPr>
-      </p:sp>
-      <p:sp>
-        <p:nvSpPr>
-          <p:cNvPr id="23" name="Text 21"/>
-          <p:cNvSpPr/>
-          <p:nvPr/>
-        </p:nvSpPr>
-        <p:spPr>
-          <a:xfrm>
-            <a:off x="6419088" y="4069080"/>
-            <a:ext cx="2194560" cy="365760"/>
-          </a:xfrm>
-          <a:prstGeom prst="rect">
-            <a:avLst/>
-          </a:prstGeom>
-          <a:noFill/>
-          <a:ln/>
-        </p:spPr>
-        <p:txBody>
-          <a:bodyPr wrap="square" lIns="0" tIns="0" rIns="0" bIns="0" rtlCol="0" anchor="t"/>
-          <a:lstStyle/>
-          <a:p>
-            <a:pPr indent="0" marL="0">
-              <a:buNone/>
-            </a:pPr>
-            <a:r>
-              <a:rPr lang="en-US" sz="2000" dirty="0">
-                <a:solidFill>
-                  <a:srgbClr val="C6A46A"/>
-                </a:solidFill>
-                <a:latin typeface="Georgia" pitchFamily="34" charset="0"/>
-                <a:ea typeface="Georgia" pitchFamily="34" charset="-122"/>
-                <a:cs typeface="Georgia" pitchFamily="34" charset="-120"/>
-              </a:rPr>
-              <a:t>E3</a:t>
-            </a:r>
-            <a:endParaRPr lang="en-US" sz="2000" dirty="0"/>
-          </a:p>
-        </p:txBody>
-      </p:sp>
-      <p:sp>
-        <p:nvSpPr>
-          <p:cNvPr id="24" name="Text 22"/>
-          <p:cNvSpPr/>
-          <p:nvPr/>
-        </p:nvSpPr>
-        <p:spPr>
-          <a:xfrm>
-            <a:off x="6419088" y="4069080"/>
-            <a:ext cx="2194560" cy="365760"/>
-          </a:xfrm>
-          <a:prstGeom prst="rect">
-            <a:avLst/>
-          </a:prstGeom>
-          <a:noFill/>
-          <a:ln/>
-        </p:spPr>
-        <p:txBody>
-          <a:bodyPr wrap="square" lIns="0" tIns="0" rIns="0" bIns="0" rtlCol="0" anchor="t"/>
-          <a:lstStyle/>
-          <a:p>
-            <a:pPr algn="r" indent="0" marL="0">
-              <a:buNone/>
-            </a:pPr>
-            <a:r>
-              <a:rPr lang="en-US" sz="1150" dirty="0">
-                <a:solidFill>
-                  <a:srgbClr val="9A8A72"/>
-                </a:solidFill>
-                <a:latin typeface="Helvetica Neue" pitchFamily="34" charset="0"/>
-                <a:ea typeface="Helvetica Neue" pitchFamily="34" charset="-122"/>
-                <a:cs typeface="Helvetica Neue" pitchFamily="34" charset="-120"/>
-              </a:rPr>
-              <a:t>~12 min</a:t>
-            </a:r>
-            <a:endParaRPr lang="en-US" sz="1150" dirty="0"/>
-          </a:p>
-        </p:txBody>
-      </p:sp>
-      <p:sp>
-        <p:nvSpPr>
-          <p:cNvPr id="25" name="Text 23"/>
-          <p:cNvSpPr/>
-          <p:nvPr/>
-        </p:nvSpPr>
-        <p:spPr>
-          <a:xfrm>
-            <a:off x="6419088" y="4526280"/>
-            <a:ext cx="2194560" cy="411480"/>
-          </a:xfrm>
-          <a:prstGeom prst="rect">
-            <a:avLst/>
-          </a:prstGeom>
-          <a:noFill/>
-          <a:ln/>
-        </p:spPr>
-        <p:txBody>
-          <a:bodyPr wrap="square" lIns="0" tIns="0" rIns="0" bIns="0" rtlCol="0" anchor="t">
-            <a:normAutofit/>
-          </a:bodyPr>
-          <a:lstStyle/>
-          <a:p>
-            <a:pPr indent="0" marL="0">
-              <a:buNone/>
-            </a:pPr>
-            <a:r>
-              <a:rPr lang="en-US" sz="1400" b="1" dirty="0">
-                <a:solidFill>
-                  <a:srgbClr val="FCFAF4"/>
-                </a:solidFill>
-                <a:latin typeface="Helvetica Neue" pitchFamily="34" charset="0"/>
-                <a:ea typeface="Helvetica Neue" pitchFamily="34" charset="-122"/>
-                <a:cs typeface="Helvetica Neue" pitchFamily="34" charset="-120"/>
-              </a:rPr>
-              <a:t>Fix the reader</a:t>
-            </a:r>
-            <a:endParaRPr lang="en-US" sz="1400" dirty="0"/>
-          </a:p>
-        </p:txBody>
-      </p:sp>
-      <p:sp>
-        <p:nvSpPr>
-          <p:cNvPr id="26" name="Text 24"/>
-          <p:cNvSpPr/>
-          <p:nvPr/>
-        </p:nvSpPr>
-        <p:spPr>
-          <a:xfrm>
-            <a:off x="6419088" y="4956048"/>
-            <a:ext cx="2194560" cy="548640"/>
-          </a:xfrm>
-          <a:prstGeom prst="rect">
-            <a:avLst/>
-          </a:prstGeom>
-          <a:noFill/>
-          <a:ln/>
-        </p:spPr>
-        <p:txBody>
-          <a:bodyPr wrap="square" lIns="0" tIns="0" rIns="0" bIns="0" rtlCol="0" anchor="t"/>
-          <a:lstStyle/>
-          <a:p>
-            <a:pPr indent="0" marL="0">
-              <a:buNone/>
-            </a:pPr>
-            <a:r>
-              <a:rPr lang="en-US" sz="1150" dirty="0">
-                <a:solidFill>
-                  <a:srgbClr val="C9BDA4"/>
-                </a:solidFill>
-                <a:latin typeface="Helvetica Neue" pitchFamily="34" charset="0"/>
-                <a:ea typeface="Helvetica Neue" pitchFamily="34" charset="-122"/>
-                <a:cs typeface="Helvetica Neue" pitchFamily="34" charset="-120"/>
-              </a:rPr>
-              <a:t>slice the index across cores</a:t>
-            </a:r>
-            <a:endParaRPr lang="en-US" sz="1150" dirty="0"/>
-          </a:p>
-        </p:txBody>
-      </p:sp>
-      <p:sp>
-        <p:nvSpPr>
-          <p:cNvPr id="27" name="Shape 25"/>
-          <p:cNvSpPr/>
-          <p:nvPr/>
-        </p:nvSpPr>
-        <p:spPr>
-          <a:xfrm>
-            <a:off x="8961120" y="3886200"/>
-            <a:ext cx="2560320" cy="1691640"/>
-          </a:xfrm>
-          <a:prstGeom prst="roundRect">
-            <a:avLst>
-              <a:gd name="adj" fmla="val 4324"/>
-            </a:avLst>
-          </a:prstGeom>
-          <a:solidFill>
-            <a:srgbClr val="3B3220"/>
-          </a:solidFill>
-          <a:ln/>
-        </p:spPr>
-      </p:sp>
-      <p:sp>
-        <p:nvSpPr>
-          <p:cNvPr id="28" name="Shape 26"/>
-          <p:cNvSpPr/>
-          <p:nvPr/>
-        </p:nvSpPr>
-        <p:spPr>
-          <a:xfrm>
-            <a:off x="8961120" y="3886200"/>
-            <a:ext cx="2560320" cy="91440"/>
-          </a:xfrm>
-          <a:prstGeom prst="rect">
-            <a:avLst/>
-          </a:prstGeom>
-          <a:solidFill>
-            <a:srgbClr val="A8864A"/>
-          </a:solidFill>
-          <a:ln/>
-        </p:spPr>
-      </p:sp>
-      <p:sp>
-        <p:nvSpPr>
-          <p:cNvPr id="29" name="Text 27"/>
-          <p:cNvSpPr/>
-          <p:nvPr/>
-        </p:nvSpPr>
-        <p:spPr>
-          <a:xfrm>
-            <a:off x="9162288" y="4069080"/>
-            <a:ext cx="2194560" cy="365760"/>
-          </a:xfrm>
-          <a:prstGeom prst="rect">
-            <a:avLst/>
-          </a:prstGeom>
-          <a:noFill/>
-          <a:ln/>
-        </p:spPr>
-        <p:txBody>
-          <a:bodyPr wrap="square" lIns="0" tIns="0" rIns="0" bIns="0" rtlCol="0" anchor="t"/>
-          <a:lstStyle/>
-          <a:p>
-            <a:pPr indent="0" marL="0">
-              <a:buNone/>
-            </a:pPr>
-            <a:r>
-              <a:rPr lang="en-US" sz="2000" dirty="0">
-                <a:solidFill>
-                  <a:srgbClr val="C6A46A"/>
-                </a:solidFill>
-                <a:latin typeface="Georgia" pitchFamily="34" charset="0"/>
-                <a:ea typeface="Georgia" pitchFamily="34" charset="-122"/>
-                <a:cs typeface="Georgia" pitchFamily="34" charset="-120"/>
-              </a:rPr>
-              <a:t>E4</a:t>
-            </a:r>
-            <a:endParaRPr lang="en-US" sz="2000" dirty="0"/>
-          </a:p>
-        </p:txBody>
-      </p:sp>
-      <p:sp>
-        <p:nvSpPr>
-          <p:cNvPr id="30" name="Text 28"/>
-          <p:cNvSpPr/>
-          <p:nvPr/>
-        </p:nvSpPr>
-        <p:spPr>
-          <a:xfrm>
-            <a:off x="9162288" y="4069080"/>
-            <a:ext cx="2194560" cy="365760"/>
-          </a:xfrm>
-          <a:prstGeom prst="rect">
-            <a:avLst/>
-          </a:prstGeom>
-          <a:noFill/>
-          <a:ln/>
-        </p:spPr>
-        <p:txBody>
-          <a:bodyPr wrap="square" lIns="0" tIns="0" rIns="0" bIns="0" rtlCol="0" anchor="t"/>
-          <a:lstStyle/>
-          <a:p>
-            <a:pPr algn="r" indent="0" marL="0">
-              <a:buNone/>
-            </a:pPr>
-            <a:r>
-              <a:rPr lang="en-US" sz="1150" dirty="0">
-                <a:solidFill>
-                  <a:srgbClr val="9A8A72"/>
-                </a:solidFill>
-                <a:latin typeface="Helvetica Neue" pitchFamily="34" charset="0"/>
-                <a:ea typeface="Helvetica Neue" pitchFamily="34" charset="-122"/>
-                <a:cs typeface="Helvetica Neue" pitchFamily="34" charset="-120"/>
-              </a:rPr>
-              <a:t>~15 min</a:t>
-            </a:r>
-            <a:endParaRPr lang="en-US" sz="1150" dirty="0"/>
-          </a:p>
-        </p:txBody>
-      </p:sp>
-      <p:sp>
-        <p:nvSpPr>
-          <p:cNvPr id="31" name="Text 29"/>
-          <p:cNvSpPr/>
-          <p:nvPr/>
-        </p:nvSpPr>
-        <p:spPr>
-          <a:xfrm>
-            <a:off x="9162288" y="4526280"/>
-            <a:ext cx="2194560" cy="411480"/>
-          </a:xfrm>
-          <a:prstGeom prst="rect">
-            <a:avLst/>
-          </a:prstGeom>
-          <a:noFill/>
-          <a:ln/>
-        </p:spPr>
-        <p:txBody>
-          <a:bodyPr wrap="square" lIns="0" tIns="0" rIns="0" bIns="0" rtlCol="0" anchor="t">
-            <a:normAutofit/>
-          </a:bodyPr>
-          <a:lstStyle/>
-          <a:p>
-            <a:pPr indent="0" marL="0">
-              <a:buNone/>
-            </a:pPr>
-            <a:r>
-              <a:rPr lang="en-US" sz="1400" b="1" dirty="0">
-                <a:solidFill>
-                  <a:srgbClr val="FCFAF4"/>
-                </a:solidFill>
-                <a:latin typeface="Helvetica Neue" pitchFamily="34" charset="0"/>
-                <a:ea typeface="Helvetica Neue" pitchFamily="34" charset="-122"/>
-                <a:cs typeface="Helvetica Neue" pitchFamily="34" charset="-120"/>
-              </a:rPr>
-              <a:t>Ship the fix</a:t>
-            </a:r>
-            <a:endParaRPr lang="en-US" sz="1400" dirty="0"/>
-          </a:p>
-        </p:txBody>
-      </p:sp>
-      <p:sp>
-        <p:nvSpPr>
-          <p:cNvPr id="32" name="Text 30"/>
-          <p:cNvSpPr/>
-          <p:nvPr/>
-        </p:nvSpPr>
-        <p:spPr>
-          <a:xfrm>
-            <a:off x="9162288" y="4956048"/>
-            <a:ext cx="2194560" cy="548640"/>
-          </a:xfrm>
-          <a:prstGeom prst="rect">
-            <a:avLst/>
-          </a:prstGeom>
-          <a:noFill/>
-          <a:ln/>
-        </p:spPr>
-        <p:txBody>
-          <a:bodyPr wrap="square" lIns="0" tIns="0" rIns="0" bIns="0" rtlCol="0" anchor="t"/>
-          <a:lstStyle/>
-          <a:p>
-            <a:pPr indent="0" marL="0">
-              <a:buNone/>
-            </a:pPr>
-            <a:r>
-              <a:rPr lang="en-US" sz="1150" dirty="0">
-                <a:solidFill>
-                  <a:srgbClr val="C9BDA4"/>
-                </a:solidFill>
-                <a:latin typeface="Helvetica Neue" pitchFamily="34" charset="0"/>
-                <a:ea typeface="Helvetica Neue" pitchFamily="34" charset="-122"/>
-                <a:cs typeface="Helvetica Neue" pitchFamily="34" charset="-120"/>
-              </a:rPr>
-              <a:t>warm, sync, rollout order</a:t>
-            </a:r>
-            <a:endParaRPr lang="en-US" sz="1150" dirty="0"/>
-          </a:p>
-        </p:txBody>
-      </p:sp>
-      <p:sp>
-        <p:nvSpPr>
-          <p:cNvPr id="33" name="Text 31"/>
-          <p:cNvSpPr/>
-          <p:nvPr/>
-        </p:nvSpPr>
-        <p:spPr>
-          <a:xfrm>
-            <a:off x="731520" y="5760720"/>
-            <a:ext cx="10515600" cy="640080"/>
-          </a:xfrm>
-          <a:prstGeom prst="rect">
-            <a:avLst/>
-          </a:prstGeom>
-          <a:noFill/>
-          <a:ln/>
-        </p:spPr>
-        <p:txBody>
-          <a:bodyPr wrap="square" lIns="0" tIns="0" rIns="0" bIns="0" rtlCol="0" anchor="t"/>
-          <a:lstStyle/>
-          <a:p>
-            <a:pPr indent="0" marL="0">
-              <a:buNone/>
-            </a:pPr>
-            <a:r>
-              <a:rPr lang="en-US" sz="1250" i="1" dirty="0">
-                <a:solidFill>
-                  <a:srgbClr val="9A8A72"/>
-                </a:solidFill>
-                <a:latin typeface="Helvetica Neue" pitchFamily="34" charset="0"/>
-                <a:ea typeface="Helvetica Neue" pitchFamily="34" charset="-122"/>
-                <a:cs typeface="Helvetica Neue" pitchFamily="34" charset="-120"/>
-              </a:rPr>
-              <a:t>Fill-the-gaps (___), solutions at the bottom of the file. Everything runs on datomic:mem:// — no Docker, no transactor, no $DATOMIC. Where an exercise checks a duration it checks a ratio or a boolean, never a millisecond count.</a:t>
-            </a:r>
-            <a:endParaRPr lang="en-US" sz="1250" dirty="0"/>
-          </a:p>
-        </p:txBody>
-      </p:sp>
-      <p:sp>
-        <p:nvSpPr>
-          <p:cNvPr id="34" name="Text 32"/>
-          <p:cNvSpPr/>
-          <p:nvPr/>
-        </p:nvSpPr>
-        <p:spPr>
-          <a:xfrm>
-            <a:off x="11155680" y="6446520"/>
-            <a:ext cx="640080" cy="256032"/>
-          </a:xfrm>
-          <a:prstGeom prst="rect">
-            <a:avLst/>
-          </a:prstGeom>
-          <a:noFill/>
-          <a:ln/>
-        </p:spPr>
-        <p:txBody>
-          <a:bodyPr wrap="square" lIns="0" tIns="0" rIns="0" bIns="0" rtlCol="0" anchor="t"/>
-          <a:lstStyle/>
-          <a:p>
-            <a:pPr algn="r" indent="0" marL="0">
-              <a:buNone/>
-            </a:pPr>
-            <a:r>
-              <a:rPr lang="en-US" sz="1100" dirty="0">
-                <a:solidFill>
-                  <a:srgbClr val="9A8A72"/>
-                </a:solidFill>
-                <a:latin typeface="Helvetica Neue" pitchFamily="34" charset="0"/>
-                <a:ea typeface="Helvetica Neue" pitchFamily="34" charset="-122"/>
-                <a:cs typeface="Helvetica Neue" pitchFamily="34" charset="-120"/>
-              </a:rPr>
-              <a:t>41</a:t>
-            </a:r>
-            <a:endParaRPr lang="en-US" sz="1100" dirty="0"/>
-          </a:p>
-        </p:txBody>
-      </p:sp>
-    </p:spTree>
-  </p:cSld>
-  <p:clrMapOvr>
-    <a:masterClrMapping/>
-  </p:clrMapOvr>
-</p:sld>
-</file>
-
-<file path=ppt/slides/slide42.xml><?xml version="1.0" encoding="utf-8"?>
-<p:sld xmlns:a="http://schemas.openxmlformats.org/drawingml/2006/main" xmlns:r="http://schemas.openxmlformats.org/officeDocument/2006/relationships" xmlns:p="http://schemas.openxmlformats.org/presentationml/2006/main">
-  <p:cSld name="Slide 42">
-    <p:spTree>
-      <p:nvGrpSpPr>
-        <p:cNvPr id="1" name=""/>
-        <p:cNvGrpSpPr/>
-        <p:nvPr/>
-      </p:nvGrpSpPr>
-      <p:grpSpPr>
-        <a:xfrm>
-          <a:off x="0" y="0"/>
-          <a:ext cx="0" cy="0"/>
-          <a:chOff x="0" y="0"/>
-          <a:chExt cx="0" cy="0"/>
-        </a:xfrm>
-      </p:grpSpPr>
-      <p:sp>
-        <p:nvSpPr>
-          <p:cNvPr id="2" name="Shape 0"/>
-          <p:cNvSpPr/>
-          <p:nvPr/>
-        </p:nvSpPr>
-        <p:spPr>
-          <a:xfrm>
-            <a:off x="0" y="0"/>
-            <a:ext cx="12191695" cy="6858000"/>
-          </a:xfrm>
-          <a:prstGeom prst="rect">
-            <a:avLst/>
-          </a:prstGeom>
-          <a:solidFill>
             <a:srgbClr val="EFE9DD"/>
           </a:solidFill>
           <a:ln/>
@@ -40100,7 +38604,7 @@
                 <a:ea typeface="Helvetica Neue" pitchFamily="34" charset="-122"/>
                 <a:cs typeface="Helvetica Neue" pitchFamily="34" charset="-120"/>
               </a:rPr>
-              <a:t>42</a:t>
+              <a:t>41</a:t>
             </a:r>
             <a:endParaRPr lang="en-US" sz="1100" dirty="0"/>
           </a:p>

</xml_diff>